<commit_message>
Add glossary; distinguish balance sensitivity from deposit beta
The simulator's beta measures balance outflow per point of rate cut, which is an
elasticity, not the standard pass-through deposit beta. Presenting to a licensed
bank, conflating the two risks the credibility of the pricing section, so the
materials now say balance sensitivity and name the distinction explicitly.

Co-Authored-By: Claude Opus 5 <noreply@anthropic.com>
Claude-Session: https://claude.ai/code/session_01W3HQLXSfDsZKWSgdamaReC
</commit_message>
<xml_diff>
--- a/deck/Core_Mexico_Business_Case.pptx
+++ b/deck/Core_Mexico_Business_Case.pptx
@@ -7362,7 +7362,7 @@
                 <a:ea typeface="Calibri" pitchFamily="34" charset="-122"/>
                 <a:cs typeface="Calibri" pitchFamily="34" charset="-120"/>
               </a:rPr>
-              <a:t>β constant. It is not: it rises once a licensed competitor advertises against us</a:t>
+              <a:t>Balance sensitivity constant. It is not — it rises once a licensed competitor advertises against us</a:t>
             </a:r>
             <a:endParaRPr lang="en-US" sz="1200" dirty="0"/>
           </a:p>
@@ -7474,7 +7474,7 @@
                 <a:ea typeface="Calibri" pitchFamily="34" charset="-122"/>
                 <a:cs typeface="Calibri" pitchFamily="34" charset="-120"/>
               </a:rPr>
-              <a:t>Is β blended, or do you have it by segment?</a:t>
+              <a:t>Is balance sensitivity blended, or do you have it by segment?</a:t>
             </a:r>
             <a:endParaRPr lang="en-US" sz="1200" dirty="0"/>
           </a:p>
@@ -13115,7 +13115,7 @@
                 <a:ea typeface="Calibri" pitchFamily="34" charset="-122"/>
                 <a:cs typeface="Calibri" pitchFamily="34" charset="-120"/>
               </a:rPr>
-              <a:t>Instrument β by segment via a geographic holdout</a:t>
+              <a:t>Instrument balance sensitivity by segment, via a geographic holdout</a:t>
             </a:r>
             <a:endParaRPr lang="en-US" sz="1200" dirty="0"/>
           </a:p>
@@ -14204,7 +14204,7 @@
                 <a:ea typeface="Arial" pitchFamily="34" charset="-122"/>
                 <a:cs typeface="Arial" pitchFamily="34" charset="-120"/>
               </a:rPr>
-              <a:t>Segment β. Never blend it.</a:t>
+              <a:t>Segment balance sensitivity. Never blend it.</a:t>
             </a:r>
             <a:endParaRPr lang="en-US" sz="1350" dirty="0"/>
           </a:p>
@@ -14246,7 +14246,7 @@
                 <a:ea typeface="Calibri" pitchFamily="34" charset="-122"/>
                 <a:cs typeface="Calibri" pitchFamily="34" charset="-120"/>
               </a:rPr>
-              <a:t>The base is two populations: brand-acquired at β near zero, and rate-shoppers. A blended β makes every cut look safe until it suddenly is not.</a:t>
+              <a:t>Balances that leave per point of rate cut — not the pass-through “deposit beta”. The base is two populations: brand-acquired and near-insensitive, and rate-shoppers. Blending them makes every cut look safe until it is not.</a:t>
             </a:r>
             <a:endParaRPr lang="en-US" sz="1150" dirty="0"/>
           </a:p>
@@ -14504,7 +14504,7 @@
                 <a:ea typeface="Calibri" pitchFamily="34" charset="-122"/>
                 <a:cs typeface="Calibri" pitchFamily="34" charset="-120"/>
               </a:rPr>
-              <a:t>β by segment, from a geographic rate holdout — not a blended number</a:t>
+              <a:t>Balance sensitivity by segment, from a geographic rate holdout — not a blended number</a:t>
             </a:r>
             <a:endParaRPr lang="en-US" sz="1150" dirty="0"/>
           </a:p>
@@ -15386,7 +15386,7 @@
                 <a:ea typeface="Calibri" pitchFamily="34" charset="-122"/>
                 <a:cs typeface="Calibri" pitchFamily="34" charset="-120"/>
               </a:rPr>
-              <a:t>“Move any slider. The one I would move first is β — push it to 6 and the rate-cut story stops working. That asymmetry is the argument: a rate cut is a one-time harvest with rising risk. Income visibility compounds.”</a:t>
+              <a:t>“Move any slider. The one I would move first is balance sensitivity — push it to 6 and the rate-cut story stops working. That asymmetry is the argument: a rate cut is a one-time harvest with rising risk. Income visibility compounds.”</a:t>
             </a:r>
             <a:endParaRPr lang="en-US" sz="1200" dirty="0"/>
           </a:p>

</xml_diff>

<commit_message>
Correct the pricing section against Nu Mexico's published rate card
Verified rates: Cajita 24/7 at 6.50% (CETES 28d is 6.49%), Cajita Turbo at 13.00%
capped at MX$25,000 and gated on one card purchase per month, Ahorro Congelado at
6.55-6.80%. Turbo was 15% until 5 January 2026.

This invalidates the earlier framing. Tiering, a balance cap and a behavioural gate
already exist, so recommending them would have described the product back to the
person who built it. The pricing argument is now narrower and specific: the gate is
weak, the cap is flat, and the rate is quoted as an absolute number that forces
every cut to be announced.

Also marks the 35% loan-to-deposit ratio as second-hand pending verification -
sec.gov and nubank.com.br are both egress-blocked, so the primary release could not
be opened and the figure comes from search summaries of it.

Co-Authored-By: Claude Opus 5 <noreply@anthropic.com>
Claude-Session: https://claude.ai/code/session_01W3HQLXSfDsZKWSgdamaReC
</commit_message>
<xml_diff>
--- a/deck/Core_Mexico_Business_Case.pptx
+++ b/deck/Core_Mexico_Business_Case.pptx
@@ -1859,7 +1859,7 @@
           <a:p>
             <a:r>
               <a:rPr lang="en-US" dirty="0"/>
-              <a:t/>
+              <a:t>Critical: do NOT propose tiering, capping or behavioural gating as new ideas. Diego owned this product and all three already exist. The contribution is which gate and which cap.</a:t>
             </a:r>
             <a:endParaRPr lang="en-US" dirty="0"/>
           </a:p>
@@ -10880,9 +10880,48 @@
                 <a:ea typeface="Arial" pitchFamily="34" charset="-122"/>
                 <a:cs typeface="Arial" pitchFamily="34" charset="-120"/>
               </a:rPr>
-              <a:t>Two tiers, earned by behaviour — not by balance</a:t>
+              <a:t>The tiering already exists. Three things I would change.</a:t>
             </a:r>
             <a:endParaRPr lang="en-US" sz="3100" dirty="0"/>
+          </a:p>
+        </p:txBody>
+      </p:sp>
+      <p:sp>
+        <p:nvSpPr>
+          <p:cNvPr id="5" name="Text 3"/>
+          <p:cNvSpPr txBox="1"/>
+          <p:nvPr/>
+        </p:nvSpPr>
+        <p:spPr>
+          <a:xfrm>
+            <a:off x="566928" y="1737360"/>
+            <a:ext cx="5760720" cy="274320"/>
+          </a:xfrm>
+          <a:prstGeom prst="rect">
+            <a:avLst/>
+          </a:prstGeom>
+          <a:noFill/>
+          <a:ln/>
+        </p:spPr>
+        <p:txBody>
+          <a:bodyPr wrap="square" lIns="0" tIns="0" rIns="0" bIns="0" rtlCol="0" anchor="ctr"/>
+          <a:lstStyle/>
+          <a:p>
+            <a:pPr indent="0" marL="0">
+              <a:buNone/>
+            </a:pPr>
+            <a:r>
+              <a:rPr lang="en-US" sz="1200" i="1" dirty="0">
+                <a:solidFill>
+                  <a:srgbClr val="6E6484"/>
+                </a:solidFill>
+                <a:latin typeface="Calibri" pitchFamily="34" charset="0"/>
+                <a:ea typeface="Calibri" pitchFamily="34" charset="-122"/>
+                <a:cs typeface="Calibri" pitchFamily="34" charset="-120"/>
+              </a:rPr>
+              <a:t>Published rate card, in force 10 August to 7 October 2026</a:t>
+            </a:r>
+            <a:endParaRPr lang="en-US" sz="1200" dirty="0"/>
           </a:p>
         </p:txBody>
       </p:sp>
@@ -10901,19 +10940,19 @@
           </p:nvPr>
         </p:nvGraphicFramePr>
         <p:xfrm>
-          <a:off x="566928" y="1783080"/>
-          <a:ext cx="6492240" cy="914400"/>
+          <a:off x="566928" y="2084832"/>
+          <a:ext cx="5760720" cy="914400"/>
         </p:xfrm>
         <a:graphic>
           <a:graphicData uri="http://schemas.openxmlformats.org/drawingml/2006/table">
             <a:tbl>
               <a:tblPr/>
               <a:tblGrid>
-                <a:gridCol w="1737360"/>
-                <a:gridCol w="1920240"/>
-                <a:gridCol w="2834640"/>
+                <a:gridCol w="1600200"/>
+                <a:gridCol w="1051560"/>
+                <a:gridCol w="3108960"/>
               </a:tblGrid>
-              <a:tr h="402336">
+              <a:tr h="420624">
                 <a:tc>
                   <a:txBody>
                     <a:bodyPr/>
@@ -10922,6 +10961,223 @@
                       <a:pPr indent="0" marL="0">
                         <a:buNone/>
                       </a:pPr>
+                      <a:r>
+                        <a:rPr lang="en-US" sz="1050" b="1" dirty="0">
+                          <a:solidFill>
+                            <a:srgbClr val="6E6484"/>
+                          </a:solidFill>
+                          <a:latin typeface="Calibri" pitchFamily="34" charset="0"/>
+                          <a:ea typeface="Calibri" pitchFamily="34" charset="-122"/>
+                          <a:cs typeface="Calibri" pitchFamily="34" charset="-120"/>
+                        </a:rPr>
+                        <a:t>Product</a:t>
+                      </a:r>
+                      <a:endParaRPr lang="en-US" sz="1050" dirty="0">
+                        <a:latin typeface="Calibri" charset="0"/>
+                        <a:ea typeface="Calibri" charset="0"/>
+                        <a:cs typeface="Calibri" charset="0"/>
+                      </a:endParaRPr>
+                    </a:p>
+                  </a:txBody>
+                  <a:tcPr marL="82296" marR="82296" marT="82296" marB="82296" anchor="ctr">
+                    <a:lnL w="12700" cap="flat" cmpd="sng" algn="ctr">
+                      <a:solidFill>
+                        <a:srgbClr val="E2DCEC"/>
+                      </a:solidFill>
+                      <a:prstDash val="solid"/>
+                      <a:round/>
+                      <a:headEnd type="none" w="med" len="med"/>
+                      <a:tailEnd type="none" w="med" len="med"/>
+                    </a:lnL>
+                    <a:lnR w="12700" cap="flat" cmpd="sng" algn="ctr">
+                      <a:solidFill>
+                        <a:srgbClr val="E2DCEC"/>
+                      </a:solidFill>
+                      <a:prstDash val="solid"/>
+                      <a:round/>
+                      <a:headEnd type="none" w="med" len="med"/>
+                      <a:tailEnd type="none" w="med" len="med"/>
+                    </a:lnR>
+                    <a:lnT w="12700" cap="flat" cmpd="sng" algn="ctr">
+                      <a:solidFill>
+                        <a:srgbClr val="E2DCEC"/>
+                      </a:solidFill>
+                      <a:prstDash val="solid"/>
+                      <a:round/>
+                      <a:headEnd type="none" w="med" len="med"/>
+                      <a:tailEnd type="none" w="med" len="med"/>
+                    </a:lnT>
+                    <a:lnB w="12700" cap="flat" cmpd="sng" algn="ctr">
+                      <a:solidFill>
+                        <a:srgbClr val="E2DCEC"/>
+                      </a:solidFill>
+                      <a:prstDash val="solid"/>
+                      <a:round/>
+                      <a:headEnd type="none" w="med" len="med"/>
+                      <a:tailEnd type="none" w="med" len="med"/>
+                    </a:lnB>
+                    <a:solidFill>
+                      <a:srgbClr val="FFFFFF"/>
+                    </a:solidFill>
+                  </a:tcPr>
+                </a:tc>
+                <a:tc>
+                  <a:txBody>
+                    <a:bodyPr/>
+                    <a:lstStyle/>
+                    <a:p>
+                      <a:pPr indent="0" marL="0">
+                        <a:buNone/>
+                      </a:pPr>
+                      <a:r>
+                        <a:rPr lang="en-US" sz="1050" b="1" dirty="0">
+                          <a:solidFill>
+                            <a:srgbClr val="6E6484"/>
+                          </a:solidFill>
+                          <a:latin typeface="Calibri" pitchFamily="34" charset="0"/>
+                          <a:ea typeface="Calibri" pitchFamily="34" charset="-122"/>
+                          <a:cs typeface="Calibri" pitchFamily="34" charset="-120"/>
+                        </a:rPr>
+                        <a:t>Rate</a:t>
+                      </a:r>
+                      <a:endParaRPr lang="en-US" sz="1050" dirty="0">
+                        <a:latin typeface="Calibri" charset="0"/>
+                        <a:ea typeface="Calibri" charset="0"/>
+                        <a:cs typeface="Calibri" charset="0"/>
+                      </a:endParaRPr>
+                    </a:p>
+                  </a:txBody>
+                  <a:tcPr marL="82296" marR="82296" marT="82296" marB="82296" anchor="ctr">
+                    <a:lnL w="12700" cap="flat" cmpd="sng" algn="ctr">
+                      <a:solidFill>
+                        <a:srgbClr val="E2DCEC"/>
+                      </a:solidFill>
+                      <a:prstDash val="solid"/>
+                      <a:round/>
+                      <a:headEnd type="none" w="med" len="med"/>
+                      <a:tailEnd type="none" w="med" len="med"/>
+                    </a:lnL>
+                    <a:lnR w="12700" cap="flat" cmpd="sng" algn="ctr">
+                      <a:solidFill>
+                        <a:srgbClr val="E2DCEC"/>
+                      </a:solidFill>
+                      <a:prstDash val="solid"/>
+                      <a:round/>
+                      <a:headEnd type="none" w="med" len="med"/>
+                      <a:tailEnd type="none" w="med" len="med"/>
+                    </a:lnR>
+                    <a:lnT w="12700" cap="flat" cmpd="sng" algn="ctr">
+                      <a:solidFill>
+                        <a:srgbClr val="E2DCEC"/>
+                      </a:solidFill>
+                      <a:prstDash val="solid"/>
+                      <a:round/>
+                      <a:headEnd type="none" w="med" len="med"/>
+                      <a:tailEnd type="none" w="med" len="med"/>
+                    </a:lnT>
+                    <a:lnB w="12700" cap="flat" cmpd="sng" algn="ctr">
+                      <a:solidFill>
+                        <a:srgbClr val="E2DCEC"/>
+                      </a:solidFill>
+                      <a:prstDash val="solid"/>
+                      <a:round/>
+                      <a:headEnd type="none" w="med" len="med"/>
+                      <a:tailEnd type="none" w="med" len="med"/>
+                    </a:lnB>
+                    <a:solidFill>
+                      <a:srgbClr val="FFFFFF"/>
+                    </a:solidFill>
+                  </a:tcPr>
+                </a:tc>
+                <a:tc>
+                  <a:txBody>
+                    <a:bodyPr/>
+                    <a:lstStyle/>
+                    <a:p>
+                      <a:pPr indent="0" marL="0">
+                        <a:buNone/>
+                      </a:pPr>
+                      <a:r>
+                        <a:rPr lang="en-US" sz="1050" b="1" dirty="0">
+                          <a:solidFill>
+                            <a:srgbClr val="6E6484"/>
+                          </a:solidFill>
+                          <a:latin typeface="Calibri" pitchFamily="34" charset="0"/>
+                          <a:ea typeface="Calibri" pitchFamily="34" charset="-122"/>
+                          <a:cs typeface="Calibri" pitchFamily="34" charset="-120"/>
+                        </a:rPr>
+                        <a:t>Condition</a:t>
+                      </a:r>
+                      <a:endParaRPr lang="en-US" sz="1050" dirty="0">
+                        <a:latin typeface="Calibri" charset="0"/>
+                        <a:ea typeface="Calibri" charset="0"/>
+                        <a:cs typeface="Calibri" charset="0"/>
+                      </a:endParaRPr>
+                    </a:p>
+                  </a:txBody>
+                  <a:tcPr marL="82296" marR="82296" marT="82296" marB="82296" anchor="ctr">
+                    <a:lnL w="12700" cap="flat" cmpd="sng" algn="ctr">
+                      <a:solidFill>
+                        <a:srgbClr val="E2DCEC"/>
+                      </a:solidFill>
+                      <a:prstDash val="solid"/>
+                      <a:round/>
+                      <a:headEnd type="none" w="med" len="med"/>
+                      <a:tailEnd type="none" w="med" len="med"/>
+                    </a:lnL>
+                    <a:lnR w="12700" cap="flat" cmpd="sng" algn="ctr">
+                      <a:solidFill>
+                        <a:srgbClr val="E2DCEC"/>
+                      </a:solidFill>
+                      <a:prstDash val="solid"/>
+                      <a:round/>
+                      <a:headEnd type="none" w="med" len="med"/>
+                      <a:tailEnd type="none" w="med" len="med"/>
+                    </a:lnR>
+                    <a:lnT w="12700" cap="flat" cmpd="sng" algn="ctr">
+                      <a:solidFill>
+                        <a:srgbClr val="E2DCEC"/>
+                      </a:solidFill>
+                      <a:prstDash val="solid"/>
+                      <a:round/>
+                      <a:headEnd type="none" w="med" len="med"/>
+                      <a:tailEnd type="none" w="med" len="med"/>
+                    </a:lnT>
+                    <a:lnB w="12700" cap="flat" cmpd="sng" algn="ctr">
+                      <a:solidFill>
+                        <a:srgbClr val="E2DCEC"/>
+                      </a:solidFill>
+                      <a:prstDash val="solid"/>
+                      <a:round/>
+                      <a:headEnd type="none" w="med" len="med"/>
+                      <a:tailEnd type="none" w="med" len="med"/>
+                    </a:lnB>
+                    <a:solidFill>
+                      <a:srgbClr val="FFFFFF"/>
+                    </a:solidFill>
+                  </a:tcPr>
+                </a:tc>
+              </a:tr>
+              <a:tr h="420624">
+                <a:tc>
+                  <a:txBody>
+                    <a:bodyPr/>
+                    <a:lstStyle/>
+                    <a:p>
+                      <a:pPr indent="0" marL="0">
+                        <a:buNone/>
+                      </a:pPr>
+                      <a:r>
+                        <a:rPr lang="en-US" sz="1200" b="1" dirty="0">
+                          <a:solidFill>
+                            <a:srgbClr val="19102A"/>
+                          </a:solidFill>
+                          <a:latin typeface="Calibri" pitchFamily="34" charset="0"/>
+                          <a:ea typeface="Calibri" pitchFamily="34" charset="-122"/>
+                          <a:cs typeface="Calibri" pitchFamily="34" charset="-120"/>
+                        </a:rPr>
+                        <a:t>Cajita 24/7</a:t>
+                      </a:r>
                       <a:endParaRPr lang="en-US" sz="1200" dirty="0">
                         <a:latin typeface="Calibri" charset="0"/>
                         <a:ea typeface="Calibri" charset="0"/>
@@ -10980,155 +11236,17 @@
                         <a:buNone/>
                       </a:pPr>
                       <a:r>
-                        <a:rPr lang="en-US" sz="1500" b="1" dirty="0">
+                        <a:rPr lang="en-US" sz="1200" b="1" dirty="0">
                           <a:solidFill>
                             <a:srgbClr val="19102A"/>
-                          </a:solidFill>
-                          <a:latin typeface="Arial" pitchFamily="34" charset="0"/>
-                          <a:ea typeface="Arial" pitchFamily="34" charset="-122"/>
-                          <a:cs typeface="Arial" pitchFamily="34" charset="-120"/>
-                        </a:rPr>
-                        <a:t>Nu Base</a:t>
-                      </a:r>
-                      <a:endParaRPr lang="en-US" sz="1500" dirty="0">
-                        <a:latin typeface="Arial" charset="0"/>
-                        <a:ea typeface="Arial" charset="0"/>
-                        <a:cs typeface="Arial" charset="0"/>
-                      </a:endParaRPr>
-                    </a:p>
-                  </a:txBody>
-                  <a:tcPr marL="82296" marR="82296" marT="82296" marB="82296" anchor="ctr">
-                    <a:lnL w="12700" cap="flat" cmpd="sng" algn="ctr">
-                      <a:solidFill>
-                        <a:srgbClr val="E2DCEC"/>
-                      </a:solidFill>
-                      <a:prstDash val="solid"/>
-                      <a:round/>
-                      <a:headEnd type="none" w="med" len="med"/>
-                      <a:tailEnd type="none" w="med" len="med"/>
-                    </a:lnL>
-                    <a:lnR w="12700" cap="flat" cmpd="sng" algn="ctr">
-                      <a:solidFill>
-                        <a:srgbClr val="E2DCEC"/>
-                      </a:solidFill>
-                      <a:prstDash val="solid"/>
-                      <a:round/>
-                      <a:headEnd type="none" w="med" len="med"/>
-                      <a:tailEnd type="none" w="med" len="med"/>
-                    </a:lnR>
-                    <a:lnT w="12700" cap="flat" cmpd="sng" algn="ctr">
-                      <a:solidFill>
-                        <a:srgbClr val="E2DCEC"/>
-                      </a:solidFill>
-                      <a:prstDash val="solid"/>
-                      <a:round/>
-                      <a:headEnd type="none" w="med" len="med"/>
-                      <a:tailEnd type="none" w="med" len="med"/>
-                    </a:lnT>
-                    <a:lnB w="12700" cap="flat" cmpd="sng" algn="ctr">
-                      <a:solidFill>
-                        <a:srgbClr val="E2DCEC"/>
-                      </a:solidFill>
-                      <a:prstDash val="solid"/>
-                      <a:round/>
-                      <a:headEnd type="none" w="med" len="med"/>
-                      <a:tailEnd type="none" w="med" len="med"/>
-                    </a:lnB>
-                    <a:solidFill>
-                      <a:srgbClr val="FFFFFF"/>
-                    </a:solidFill>
-                  </a:tcPr>
-                </a:tc>
-                <a:tc>
-                  <a:txBody>
-                    <a:bodyPr/>
-                    <a:lstStyle/>
-                    <a:p>
-                      <a:pPr indent="0" marL="0">
-                        <a:buNone/>
-                      </a:pPr>
-                      <a:r>
-                        <a:rPr lang="en-US" sz="1500" b="1" dirty="0">
-                          <a:solidFill>
-                            <a:srgbClr val="820AD1"/>
-                          </a:solidFill>
-                          <a:latin typeface="Arial" pitchFamily="34" charset="0"/>
-                          <a:ea typeface="Arial" pitchFamily="34" charset="-122"/>
-                          <a:cs typeface="Arial" pitchFamily="34" charset="-120"/>
-                        </a:rPr>
-                        <a:t>Nu Nómina</a:t>
-                      </a:r>
-                      <a:endParaRPr lang="en-US" sz="1500" dirty="0">
-                        <a:latin typeface="Arial" charset="0"/>
-                        <a:ea typeface="Arial" charset="0"/>
-                        <a:cs typeface="Arial" charset="0"/>
-                      </a:endParaRPr>
-                    </a:p>
-                  </a:txBody>
-                  <a:tcPr marL="82296" marR="82296" marT="82296" marB="82296" anchor="ctr">
-                    <a:lnL w="12700" cap="flat" cmpd="sng" algn="ctr">
-                      <a:solidFill>
-                        <a:srgbClr val="E2DCEC"/>
-                      </a:solidFill>
-                      <a:prstDash val="solid"/>
-                      <a:round/>
-                      <a:headEnd type="none" w="med" len="med"/>
-                      <a:tailEnd type="none" w="med" len="med"/>
-                    </a:lnL>
-                    <a:lnR w="12700" cap="flat" cmpd="sng" algn="ctr">
-                      <a:solidFill>
-                        <a:srgbClr val="E2DCEC"/>
-                      </a:solidFill>
-                      <a:prstDash val="solid"/>
-                      <a:round/>
-                      <a:headEnd type="none" w="med" len="med"/>
-                      <a:tailEnd type="none" w="med" len="med"/>
-                    </a:lnR>
-                    <a:lnT w="12700" cap="flat" cmpd="sng" algn="ctr">
-                      <a:solidFill>
-                        <a:srgbClr val="E2DCEC"/>
-                      </a:solidFill>
-                      <a:prstDash val="solid"/>
-                      <a:round/>
-                      <a:headEnd type="none" w="med" len="med"/>
-                      <a:tailEnd type="none" w="med" len="med"/>
-                    </a:lnT>
-                    <a:lnB w="12700" cap="flat" cmpd="sng" algn="ctr">
-                      <a:solidFill>
-                        <a:srgbClr val="E2DCEC"/>
-                      </a:solidFill>
-                      <a:prstDash val="solid"/>
-                      <a:round/>
-                      <a:headEnd type="none" w="med" len="med"/>
-                      <a:tailEnd type="none" w="med" len="med"/>
-                    </a:lnB>
-                    <a:solidFill>
-                      <a:srgbClr val="FFFFFF"/>
-                    </a:solidFill>
-                  </a:tcPr>
-                </a:tc>
-              </a:tr>
-              <a:tr h="402336">
-                <a:tc>
-                  <a:txBody>
-                    <a:bodyPr/>
-                    <a:lstStyle/>
-                    <a:p>
-                      <a:pPr indent="0" marL="0">
-                        <a:buNone/>
-                      </a:pPr>
-                      <a:r>
-                        <a:rPr lang="en-US" sz="1150" b="1" dirty="0">
-                          <a:solidFill>
-                            <a:srgbClr val="6E6484"/>
                           </a:solidFill>
                           <a:latin typeface="Calibri" pitchFamily="34" charset="0"/>
                           <a:ea typeface="Calibri" pitchFamily="34" charset="-122"/>
                           <a:cs typeface="Calibri" pitchFamily="34" charset="-120"/>
                         </a:rPr>
-                        <a:t>How you qualify</a:t>
+                        <a:t>6.50%</a:t>
                       </a:r>
-                      <a:endParaRPr lang="en-US" sz="1150" dirty="0">
+                      <a:endParaRPr lang="en-US" sz="1200" dirty="0">
                         <a:latin typeface="Calibri" charset="0"/>
                         <a:ea typeface="Calibri" charset="0"/>
                         <a:cs typeface="Calibri" charset="0"/>
@@ -11186,7 +11304,7 @@
                         <a:buNone/>
                       </a:pPr>
                       <a:r>
-                        <a:rPr lang="en-US" sz="1250" dirty="0">
+                        <a:rPr lang="en-US" sz="1100" dirty="0">
                           <a:solidFill>
                             <a:srgbClr val="2F2740"/>
                           </a:solidFill>
@@ -11194,9 +11312,79 @@
                           <a:ea typeface="Calibri" pitchFamily="34" charset="-122"/>
                           <a:cs typeface="Calibri" pitchFamily="34" charset="-120"/>
                         </a:rPr>
-                        <a:t>Any customer</a:t>
+                        <a:t>None — and CETES is 6.49%</a:t>
                       </a:r>
-                      <a:endParaRPr lang="en-US" sz="1250" dirty="0">
+                      <a:endParaRPr lang="en-US" sz="1100" dirty="0">
+                        <a:latin typeface="Calibri" charset="0"/>
+                        <a:ea typeface="Calibri" charset="0"/>
+                        <a:cs typeface="Calibri" charset="0"/>
+                      </a:endParaRPr>
+                    </a:p>
+                  </a:txBody>
+                  <a:tcPr marL="82296" marR="82296" marT="82296" marB="82296" anchor="ctr">
+                    <a:lnL w="12700" cap="flat" cmpd="sng" algn="ctr">
+                      <a:solidFill>
+                        <a:srgbClr val="E2DCEC"/>
+                      </a:solidFill>
+                      <a:prstDash val="solid"/>
+                      <a:round/>
+                      <a:headEnd type="none" w="med" len="med"/>
+                      <a:tailEnd type="none" w="med" len="med"/>
+                    </a:lnL>
+                    <a:lnR w="12700" cap="flat" cmpd="sng" algn="ctr">
+                      <a:solidFill>
+                        <a:srgbClr val="E2DCEC"/>
+                      </a:solidFill>
+                      <a:prstDash val="solid"/>
+                      <a:round/>
+                      <a:headEnd type="none" w="med" len="med"/>
+                      <a:tailEnd type="none" w="med" len="med"/>
+                    </a:lnR>
+                    <a:lnT w="12700" cap="flat" cmpd="sng" algn="ctr">
+                      <a:solidFill>
+                        <a:srgbClr val="E2DCEC"/>
+                      </a:solidFill>
+                      <a:prstDash val="solid"/>
+                      <a:round/>
+                      <a:headEnd type="none" w="med" len="med"/>
+                      <a:tailEnd type="none" w="med" len="med"/>
+                    </a:lnT>
+                    <a:lnB w="12700" cap="flat" cmpd="sng" algn="ctr">
+                      <a:solidFill>
+                        <a:srgbClr val="E2DCEC"/>
+                      </a:solidFill>
+                      <a:prstDash val="solid"/>
+                      <a:round/>
+                      <a:headEnd type="none" w="med" len="med"/>
+                      <a:tailEnd type="none" w="med" len="med"/>
+                    </a:lnB>
+                    <a:solidFill>
+                      <a:srgbClr val="FFFFFF"/>
+                    </a:solidFill>
+                  </a:tcPr>
+                </a:tc>
+              </a:tr>
+              <a:tr h="420624">
+                <a:tc>
+                  <a:txBody>
+                    <a:bodyPr/>
+                    <a:lstStyle/>
+                    <a:p>
+                      <a:pPr indent="0" marL="0">
+                        <a:buNone/>
+                      </a:pPr>
+                      <a:r>
+                        <a:rPr lang="en-US" sz="1200" b="1" dirty="0">
+                          <a:solidFill>
+                            <a:srgbClr val="820AD1"/>
+                          </a:solidFill>
+                          <a:latin typeface="Calibri" pitchFamily="34" charset="0"/>
+                          <a:ea typeface="Calibri" pitchFamily="34" charset="-122"/>
+                          <a:cs typeface="Calibri" pitchFamily="34" charset="-120"/>
+                        </a:rPr>
+                        <a:t>Cajita Turbo</a:t>
+                      </a:r>
+                      <a:endParaRPr lang="en-US" sz="1200" dirty="0">
                         <a:latin typeface="Calibri" charset="0"/>
                         <a:ea typeface="Calibri" charset="0"/>
                         <a:cs typeface="Calibri" charset="0"/>
@@ -11254,87 +11442,17 @@
                         <a:buNone/>
                       </a:pPr>
                       <a:r>
-                        <a:rPr lang="en-US" sz="1250" b="1" dirty="0">
+                        <a:rPr lang="en-US" sz="1200" b="1" dirty="0">
                           <a:solidFill>
-                            <a:srgbClr val="19102A"/>
+                            <a:srgbClr val="820AD1"/>
                           </a:solidFill>
                           <a:latin typeface="Calibri" pitchFamily="34" charset="0"/>
                           <a:ea typeface="Calibri" pitchFamily="34" charset="-122"/>
                           <a:cs typeface="Calibri" pitchFamily="34" charset="-120"/>
                         </a:rPr>
-                        <a:t>Recurring income lands at Nu — documented or observed</a:t>
+                        <a:t>13.00%</a:t>
                       </a:r>
-                      <a:endParaRPr lang="en-US" sz="1250" dirty="0">
-                        <a:latin typeface="Calibri" charset="0"/>
-                        <a:ea typeface="Calibri" charset="0"/>
-                        <a:cs typeface="Calibri" charset="0"/>
-                      </a:endParaRPr>
-                    </a:p>
-                  </a:txBody>
-                  <a:tcPr marL="82296" marR="82296" marT="82296" marB="82296" anchor="ctr">
-                    <a:lnL w="12700" cap="flat" cmpd="sng" algn="ctr">
-                      <a:solidFill>
-                        <a:srgbClr val="E2DCEC"/>
-                      </a:solidFill>
-                      <a:prstDash val="solid"/>
-                      <a:round/>
-                      <a:headEnd type="none" w="med" len="med"/>
-                      <a:tailEnd type="none" w="med" len="med"/>
-                    </a:lnL>
-                    <a:lnR w="12700" cap="flat" cmpd="sng" algn="ctr">
-                      <a:solidFill>
-                        <a:srgbClr val="E2DCEC"/>
-                      </a:solidFill>
-                      <a:prstDash val="solid"/>
-                      <a:round/>
-                      <a:headEnd type="none" w="med" len="med"/>
-                      <a:tailEnd type="none" w="med" len="med"/>
-                    </a:lnR>
-                    <a:lnT w="12700" cap="flat" cmpd="sng" algn="ctr">
-                      <a:solidFill>
-                        <a:srgbClr val="E2DCEC"/>
-                      </a:solidFill>
-                      <a:prstDash val="solid"/>
-                      <a:round/>
-                      <a:headEnd type="none" w="med" len="med"/>
-                      <a:tailEnd type="none" w="med" len="med"/>
-                    </a:lnT>
-                    <a:lnB w="12700" cap="flat" cmpd="sng" algn="ctr">
-                      <a:solidFill>
-                        <a:srgbClr val="E2DCEC"/>
-                      </a:solidFill>
-                      <a:prstDash val="solid"/>
-                      <a:round/>
-                      <a:headEnd type="none" w="med" len="med"/>
-                      <a:tailEnd type="none" w="med" len="med"/>
-                    </a:lnB>
-                    <a:solidFill>
-                      <a:srgbClr val="FFFFFF"/>
-                    </a:solidFill>
-                  </a:tcPr>
-                </a:tc>
-              </a:tr>
-              <a:tr h="402336">
-                <a:tc>
-                  <a:txBody>
-                    <a:bodyPr/>
-                    <a:lstStyle/>
-                    <a:p>
-                      <a:pPr indent="0" marL="0">
-                        <a:buNone/>
-                      </a:pPr>
-                      <a:r>
-                        <a:rPr lang="en-US" sz="1150" b="1" dirty="0">
-                          <a:solidFill>
-                            <a:srgbClr val="6E6484"/>
-                          </a:solidFill>
-                          <a:latin typeface="Calibri" pitchFamily="34" charset="0"/>
-                          <a:ea typeface="Calibri" pitchFamily="34" charset="-122"/>
-                          <a:cs typeface="Calibri" pitchFamily="34" charset="-120"/>
-                        </a:rPr>
-                        <a:t>Yield</a:t>
-                      </a:r>
-                      <a:endParaRPr lang="en-US" sz="1150" dirty="0">
+                      <a:endParaRPr lang="en-US" sz="1200" dirty="0">
                         <a:latin typeface="Calibri" charset="0"/>
                         <a:ea typeface="Calibri" charset="0"/>
                         <a:cs typeface="Calibri" charset="0"/>
@@ -11392,7 +11510,7 @@
                         <a:buNone/>
                       </a:pPr>
                       <a:r>
-                        <a:rPr lang="en-US" sz="1250" dirty="0">
+                        <a:rPr lang="en-US" sz="1100" dirty="0">
                           <a:solidFill>
                             <a:srgbClr val="2F2740"/>
                           </a:solidFill>
@@ -11400,9 +11518,79 @@
                           <a:ea typeface="Calibri" pitchFamily="34" charset="-122"/>
                           <a:cs typeface="Calibri" pitchFamily="34" charset="-120"/>
                         </a:rPr>
-                        <a:t>CETES + 1.5%</a:t>
+                        <a:t>Capped at MX$25,000 · one card purchase a month</a:t>
                       </a:r>
-                      <a:endParaRPr lang="en-US" sz="1250" dirty="0">
+                      <a:endParaRPr lang="en-US" sz="1100" dirty="0">
+                        <a:latin typeface="Calibri" charset="0"/>
+                        <a:ea typeface="Calibri" charset="0"/>
+                        <a:cs typeface="Calibri" charset="0"/>
+                      </a:endParaRPr>
+                    </a:p>
+                  </a:txBody>
+                  <a:tcPr marL="82296" marR="82296" marT="82296" marB="82296" anchor="ctr">
+                    <a:lnL w="12700" cap="flat" cmpd="sng" algn="ctr">
+                      <a:solidFill>
+                        <a:srgbClr val="E2DCEC"/>
+                      </a:solidFill>
+                      <a:prstDash val="solid"/>
+                      <a:round/>
+                      <a:headEnd type="none" w="med" len="med"/>
+                      <a:tailEnd type="none" w="med" len="med"/>
+                    </a:lnL>
+                    <a:lnR w="12700" cap="flat" cmpd="sng" algn="ctr">
+                      <a:solidFill>
+                        <a:srgbClr val="E2DCEC"/>
+                      </a:solidFill>
+                      <a:prstDash val="solid"/>
+                      <a:round/>
+                      <a:headEnd type="none" w="med" len="med"/>
+                      <a:tailEnd type="none" w="med" len="med"/>
+                    </a:lnR>
+                    <a:lnT w="12700" cap="flat" cmpd="sng" algn="ctr">
+                      <a:solidFill>
+                        <a:srgbClr val="E2DCEC"/>
+                      </a:solidFill>
+                      <a:prstDash val="solid"/>
+                      <a:round/>
+                      <a:headEnd type="none" w="med" len="med"/>
+                      <a:tailEnd type="none" w="med" len="med"/>
+                    </a:lnT>
+                    <a:lnB w="12700" cap="flat" cmpd="sng" algn="ctr">
+                      <a:solidFill>
+                        <a:srgbClr val="E2DCEC"/>
+                      </a:solidFill>
+                      <a:prstDash val="solid"/>
+                      <a:round/>
+                      <a:headEnd type="none" w="med" len="med"/>
+                      <a:tailEnd type="none" w="med" len="med"/>
+                    </a:lnB>
+                    <a:solidFill>
+                      <a:srgbClr val="FFFFFF"/>
+                    </a:solidFill>
+                  </a:tcPr>
+                </a:tc>
+              </a:tr>
+              <a:tr h="420624">
+                <a:tc>
+                  <a:txBody>
+                    <a:bodyPr/>
+                    <a:lstStyle/>
+                    <a:p>
+                      <a:pPr indent="0" marL="0">
+                        <a:buNone/>
+                      </a:pPr>
+                      <a:r>
+                        <a:rPr lang="en-US" sz="1200" b="1" dirty="0">
+                          <a:solidFill>
+                            <a:srgbClr val="19102A"/>
+                          </a:solidFill>
+                          <a:latin typeface="Calibri" pitchFamily="34" charset="0"/>
+                          <a:ea typeface="Calibri" pitchFamily="34" charset="-122"/>
+                          <a:cs typeface="Calibri" pitchFamily="34" charset="-120"/>
+                        </a:rPr>
+                        <a:t>Ahorro Congelado</a:t>
+                      </a:r>
+                      <a:endParaRPr lang="en-US" sz="1200" dirty="0">
                         <a:latin typeface="Calibri" charset="0"/>
                         <a:ea typeface="Calibri" charset="0"/>
                         <a:cs typeface="Calibri" charset="0"/>
@@ -11460,7 +11648,7 @@
                         <a:buNone/>
                       </a:pPr>
                       <a:r>
-                        <a:rPr lang="en-US" sz="1250" b="1" dirty="0">
+                        <a:rPr lang="en-US" sz="1200" b="1" dirty="0">
                           <a:solidFill>
                             <a:srgbClr val="19102A"/>
                           </a:solidFill>
@@ -11468,79 +11656,9 @@
                           <a:ea typeface="Calibri" pitchFamily="34" charset="-122"/>
                           <a:cs typeface="Calibri" pitchFamily="34" charset="-120"/>
                         </a:rPr>
-                        <a:t>CETES + 4.0%, up to a balance cap</a:t>
+                        <a:t>6.55–6.80%</a:t>
                       </a:r>
-                      <a:endParaRPr lang="en-US" sz="1250" dirty="0">
-                        <a:latin typeface="Calibri" charset="0"/>
-                        <a:ea typeface="Calibri" charset="0"/>
-                        <a:cs typeface="Calibri" charset="0"/>
-                      </a:endParaRPr>
-                    </a:p>
-                  </a:txBody>
-                  <a:tcPr marL="82296" marR="82296" marT="82296" marB="82296" anchor="ctr">
-                    <a:lnL w="12700" cap="flat" cmpd="sng" algn="ctr">
-                      <a:solidFill>
-                        <a:srgbClr val="E2DCEC"/>
-                      </a:solidFill>
-                      <a:prstDash val="solid"/>
-                      <a:round/>
-                      <a:headEnd type="none" w="med" len="med"/>
-                      <a:tailEnd type="none" w="med" len="med"/>
-                    </a:lnL>
-                    <a:lnR w="12700" cap="flat" cmpd="sng" algn="ctr">
-                      <a:solidFill>
-                        <a:srgbClr val="E2DCEC"/>
-                      </a:solidFill>
-                      <a:prstDash val="solid"/>
-                      <a:round/>
-                      <a:headEnd type="none" w="med" len="med"/>
-                      <a:tailEnd type="none" w="med" len="med"/>
-                    </a:lnR>
-                    <a:lnT w="12700" cap="flat" cmpd="sng" algn="ctr">
-                      <a:solidFill>
-                        <a:srgbClr val="E2DCEC"/>
-                      </a:solidFill>
-                      <a:prstDash val="solid"/>
-                      <a:round/>
-                      <a:headEnd type="none" w="med" len="med"/>
-                      <a:tailEnd type="none" w="med" len="med"/>
-                    </a:lnT>
-                    <a:lnB w="12700" cap="flat" cmpd="sng" algn="ctr">
-                      <a:solidFill>
-                        <a:srgbClr val="E2DCEC"/>
-                      </a:solidFill>
-                      <a:prstDash val="solid"/>
-                      <a:round/>
-                      <a:headEnd type="none" w="med" len="med"/>
-                      <a:tailEnd type="none" w="med" len="med"/>
-                    </a:lnB>
-                    <a:solidFill>
-                      <a:srgbClr val="FFFFFF"/>
-                    </a:solidFill>
-                  </a:tcPr>
-                </a:tc>
-              </a:tr>
-              <a:tr h="402336">
-                <a:tc>
-                  <a:txBody>
-                    <a:bodyPr/>
-                    <a:lstStyle/>
-                    <a:p>
-                      <a:pPr indent="0" marL="0">
-                        <a:buNone/>
-                      </a:pPr>
-                      <a:r>
-                        <a:rPr lang="en-US" sz="1150" b="1" dirty="0">
-                          <a:solidFill>
-                            <a:srgbClr val="6E6484"/>
-                          </a:solidFill>
-                          <a:latin typeface="Calibri" pitchFamily="34" charset="0"/>
-                          <a:ea typeface="Calibri" pitchFamily="34" charset="-122"/>
-                          <a:cs typeface="Calibri" pitchFamily="34" charset="-120"/>
-                        </a:rPr>
-                        <a:t>Credit</a:t>
-                      </a:r>
-                      <a:endParaRPr lang="en-US" sz="1150" dirty="0">
+                      <a:endParaRPr lang="en-US" sz="1200" dirty="0">
                         <a:latin typeface="Calibri" charset="0"/>
                         <a:ea typeface="Calibri" charset="0"/>
                         <a:cs typeface="Calibri" charset="0"/>
@@ -11598,7 +11716,7 @@
                         <a:buNone/>
                       </a:pPr>
                       <a:r>
-                        <a:rPr lang="en-US" sz="1250" dirty="0">
+                        <a:rPr lang="en-US" sz="1100" dirty="0">
                           <a:solidFill>
                             <a:srgbClr val="2F2740"/>
                           </a:solidFill>
@@ -11606,489 +11724,9 @@
                           <a:ea typeface="Calibri" pitchFamily="34" charset="-122"/>
                           <a:cs typeface="Calibri" pitchFamily="34" charset="-120"/>
                         </a:rPr>
-                        <a:t>Score-based, thin</a:t>
+                        <a:t>By term</a:t>
                       </a:r>
-                      <a:endParaRPr lang="en-US" sz="1250" dirty="0">
-                        <a:latin typeface="Calibri" charset="0"/>
-                        <a:ea typeface="Calibri" charset="0"/>
-                        <a:cs typeface="Calibri" charset="0"/>
-                      </a:endParaRPr>
-                    </a:p>
-                  </a:txBody>
-                  <a:tcPr marL="82296" marR="82296" marT="82296" marB="82296" anchor="ctr">
-                    <a:lnL w="12700" cap="flat" cmpd="sng" algn="ctr">
-                      <a:solidFill>
-                        <a:srgbClr val="E2DCEC"/>
-                      </a:solidFill>
-                      <a:prstDash val="solid"/>
-                      <a:round/>
-                      <a:headEnd type="none" w="med" len="med"/>
-                      <a:tailEnd type="none" w="med" len="med"/>
-                    </a:lnL>
-                    <a:lnR w="12700" cap="flat" cmpd="sng" algn="ctr">
-                      <a:solidFill>
-                        <a:srgbClr val="E2DCEC"/>
-                      </a:solidFill>
-                      <a:prstDash val="solid"/>
-                      <a:round/>
-                      <a:headEnd type="none" w="med" len="med"/>
-                      <a:tailEnd type="none" w="med" len="med"/>
-                    </a:lnR>
-                    <a:lnT w="12700" cap="flat" cmpd="sng" algn="ctr">
-                      <a:solidFill>
-                        <a:srgbClr val="E2DCEC"/>
-                      </a:solidFill>
-                      <a:prstDash val="solid"/>
-                      <a:round/>
-                      <a:headEnd type="none" w="med" len="med"/>
-                      <a:tailEnd type="none" w="med" len="med"/>
-                    </a:lnT>
-                    <a:lnB w="12700" cap="flat" cmpd="sng" algn="ctr">
-                      <a:solidFill>
-                        <a:srgbClr val="E2DCEC"/>
-                      </a:solidFill>
-                      <a:prstDash val="solid"/>
-                      <a:round/>
-                      <a:headEnd type="none" w="med" len="med"/>
-                      <a:tailEnd type="none" w="med" len="med"/>
-                    </a:lnB>
-                    <a:solidFill>
-                      <a:srgbClr val="FFFFFF"/>
-                    </a:solidFill>
-                  </a:tcPr>
-                </a:tc>
-                <a:tc>
-                  <a:txBody>
-                    <a:bodyPr/>
-                    <a:lstStyle/>
-                    <a:p>
-                      <a:pPr indent="0" marL="0">
-                        <a:buNone/>
-                      </a:pPr>
-                      <a:r>
-                        <a:rPr lang="en-US" sz="1250" b="1" dirty="0">
-                          <a:solidFill>
-                            <a:srgbClr val="19102A"/>
-                          </a:solidFill>
-                          <a:latin typeface="Calibri" pitchFamily="34" charset="0"/>
-                          <a:ea typeface="Calibri" pitchFamily="34" charset="-122"/>
-                          <a:cs typeface="Calibri" pitchFamily="34" charset="-120"/>
-                        </a:rPr>
-                        <a:t>Line sized on observed income</a:t>
-                      </a:r>
-                      <a:endParaRPr lang="en-US" sz="1250" dirty="0">
-                        <a:latin typeface="Calibri" charset="0"/>
-                        <a:ea typeface="Calibri" charset="0"/>
-                        <a:cs typeface="Calibri" charset="0"/>
-                      </a:endParaRPr>
-                    </a:p>
-                  </a:txBody>
-                  <a:tcPr marL="82296" marR="82296" marT="82296" marB="82296" anchor="ctr">
-                    <a:lnL w="12700" cap="flat" cmpd="sng" algn="ctr">
-                      <a:solidFill>
-                        <a:srgbClr val="E2DCEC"/>
-                      </a:solidFill>
-                      <a:prstDash val="solid"/>
-                      <a:round/>
-                      <a:headEnd type="none" w="med" len="med"/>
-                      <a:tailEnd type="none" w="med" len="med"/>
-                    </a:lnL>
-                    <a:lnR w="12700" cap="flat" cmpd="sng" algn="ctr">
-                      <a:solidFill>
-                        <a:srgbClr val="E2DCEC"/>
-                      </a:solidFill>
-                      <a:prstDash val="solid"/>
-                      <a:round/>
-                      <a:headEnd type="none" w="med" len="med"/>
-                      <a:tailEnd type="none" w="med" len="med"/>
-                    </a:lnR>
-                    <a:lnT w="12700" cap="flat" cmpd="sng" algn="ctr">
-                      <a:solidFill>
-                        <a:srgbClr val="E2DCEC"/>
-                      </a:solidFill>
-                      <a:prstDash val="solid"/>
-                      <a:round/>
-                      <a:headEnd type="none" w="med" len="med"/>
-                      <a:tailEnd type="none" w="med" len="med"/>
-                    </a:lnT>
-                    <a:lnB w="12700" cap="flat" cmpd="sng" algn="ctr">
-                      <a:solidFill>
-                        <a:srgbClr val="E2DCEC"/>
-                      </a:solidFill>
-                      <a:prstDash val="solid"/>
-                      <a:round/>
-                      <a:headEnd type="none" w="med" len="med"/>
-                      <a:tailEnd type="none" w="med" len="med"/>
-                    </a:lnB>
-                    <a:solidFill>
-                      <a:srgbClr val="FFFFFF"/>
-                    </a:solidFill>
-                  </a:tcPr>
-                </a:tc>
-              </a:tr>
-              <a:tr h="402336">
-                <a:tc>
-                  <a:txBody>
-                    <a:bodyPr/>
-                    <a:lstStyle/>
-                    <a:p>
-                      <a:pPr indent="0" marL="0">
-                        <a:buNone/>
-                      </a:pPr>
-                      <a:r>
-                        <a:rPr lang="en-US" sz="1150" b="1" dirty="0">
-                          <a:solidFill>
-                            <a:srgbClr val="6E6484"/>
-                          </a:solidFill>
-                          <a:latin typeface="Calibri" pitchFamily="34" charset="0"/>
-                          <a:ea typeface="Calibri" pitchFamily="34" charset="-122"/>
-                          <a:cs typeface="Calibri" pitchFamily="34" charset="-120"/>
-                        </a:rPr>
-                        <a:t>Protection</a:t>
-                      </a:r>
-                      <a:endParaRPr lang="en-US" sz="1150" dirty="0">
-                        <a:latin typeface="Calibri" charset="0"/>
-                        <a:ea typeface="Calibri" charset="0"/>
-                        <a:cs typeface="Calibri" charset="0"/>
-                      </a:endParaRPr>
-                    </a:p>
-                  </a:txBody>
-                  <a:tcPr marL="82296" marR="82296" marT="82296" marB="82296" anchor="ctr">
-                    <a:lnL w="12700" cap="flat" cmpd="sng" algn="ctr">
-                      <a:solidFill>
-                        <a:srgbClr val="E2DCEC"/>
-                      </a:solidFill>
-                      <a:prstDash val="solid"/>
-                      <a:round/>
-                      <a:headEnd type="none" w="med" len="med"/>
-                      <a:tailEnd type="none" w="med" len="med"/>
-                    </a:lnL>
-                    <a:lnR w="12700" cap="flat" cmpd="sng" algn="ctr">
-                      <a:solidFill>
-                        <a:srgbClr val="E2DCEC"/>
-                      </a:solidFill>
-                      <a:prstDash val="solid"/>
-                      <a:round/>
-                      <a:headEnd type="none" w="med" len="med"/>
-                      <a:tailEnd type="none" w="med" len="med"/>
-                    </a:lnR>
-                    <a:lnT w="12700" cap="flat" cmpd="sng" algn="ctr">
-                      <a:solidFill>
-                        <a:srgbClr val="E2DCEC"/>
-                      </a:solidFill>
-                      <a:prstDash val="solid"/>
-                      <a:round/>
-                      <a:headEnd type="none" w="med" len="med"/>
-                      <a:tailEnd type="none" w="med" len="med"/>
-                    </a:lnT>
-                    <a:lnB w="12700" cap="flat" cmpd="sng" algn="ctr">
-                      <a:solidFill>
-                        <a:srgbClr val="E2DCEC"/>
-                      </a:solidFill>
-                      <a:prstDash val="solid"/>
-                      <a:round/>
-                      <a:headEnd type="none" w="med" len="med"/>
-                      <a:tailEnd type="none" w="med" len="med"/>
-                    </a:lnB>
-                    <a:solidFill>
-                      <a:srgbClr val="FFFFFF"/>
-                    </a:solidFill>
-                  </a:tcPr>
-                </a:tc>
-                <a:tc>
-                  <a:txBody>
-                    <a:bodyPr/>
-                    <a:lstStyle/>
-                    <a:p>
-                      <a:pPr indent="0" marL="0">
-                        <a:buNone/>
-                      </a:pPr>
-                      <a:r>
-                        <a:rPr lang="en-US" sz="1250" dirty="0">
-                          <a:solidFill>
-                            <a:srgbClr val="2F2740"/>
-                          </a:solidFill>
-                          <a:latin typeface="Calibri" pitchFamily="34" charset="0"/>
-                          <a:ea typeface="Calibri" pitchFamily="34" charset="-122"/>
-                          <a:cs typeface="Calibri" pitchFamily="34" charset="-120"/>
-                        </a:rPr>
-                        <a:t>Optional</a:t>
-                      </a:r>
-                      <a:endParaRPr lang="en-US" sz="1250" dirty="0">
-                        <a:latin typeface="Calibri" charset="0"/>
-                        <a:ea typeface="Calibri" charset="0"/>
-                        <a:cs typeface="Calibri" charset="0"/>
-                      </a:endParaRPr>
-                    </a:p>
-                  </a:txBody>
-                  <a:tcPr marL="82296" marR="82296" marT="82296" marB="82296" anchor="ctr">
-                    <a:lnL w="12700" cap="flat" cmpd="sng" algn="ctr">
-                      <a:solidFill>
-                        <a:srgbClr val="E2DCEC"/>
-                      </a:solidFill>
-                      <a:prstDash val="solid"/>
-                      <a:round/>
-                      <a:headEnd type="none" w="med" len="med"/>
-                      <a:tailEnd type="none" w="med" len="med"/>
-                    </a:lnL>
-                    <a:lnR w="12700" cap="flat" cmpd="sng" algn="ctr">
-                      <a:solidFill>
-                        <a:srgbClr val="E2DCEC"/>
-                      </a:solidFill>
-                      <a:prstDash val="solid"/>
-                      <a:round/>
-                      <a:headEnd type="none" w="med" len="med"/>
-                      <a:tailEnd type="none" w="med" len="med"/>
-                    </a:lnR>
-                    <a:lnT w="12700" cap="flat" cmpd="sng" algn="ctr">
-                      <a:solidFill>
-                        <a:srgbClr val="E2DCEC"/>
-                      </a:solidFill>
-                      <a:prstDash val="solid"/>
-                      <a:round/>
-                      <a:headEnd type="none" w="med" len="med"/>
-                      <a:tailEnd type="none" w="med" len="med"/>
-                    </a:lnT>
-                    <a:lnB w="12700" cap="flat" cmpd="sng" algn="ctr">
-                      <a:solidFill>
-                        <a:srgbClr val="E2DCEC"/>
-                      </a:solidFill>
-                      <a:prstDash val="solid"/>
-                      <a:round/>
-                      <a:headEnd type="none" w="med" len="med"/>
-                      <a:tailEnd type="none" w="med" len="med"/>
-                    </a:lnB>
-                    <a:solidFill>
-                      <a:srgbClr val="FFFFFF"/>
-                    </a:solidFill>
-                  </a:tcPr>
-                </a:tc>
-                <a:tc>
-                  <a:txBody>
-                    <a:bodyPr/>
-                    <a:lstStyle/>
-                    <a:p>
-                      <a:pPr indent="0" marL="0">
-                        <a:buNone/>
-                      </a:pPr>
-                      <a:r>
-                        <a:rPr lang="en-US" sz="1250" b="1" dirty="0">
-                          <a:solidFill>
-                            <a:srgbClr val="19102A"/>
-                          </a:solidFill>
-                          <a:latin typeface="Calibri" pitchFamily="34" charset="0"/>
-                          <a:ea typeface="Calibri" pitchFamily="34" charset="-122"/>
-                          <a:cs typeface="Calibri" pitchFamily="34" charset="-120"/>
-                        </a:rPr>
-                        <a:t>Micro-cover included</a:t>
-                      </a:r>
-                      <a:endParaRPr lang="en-US" sz="1250" dirty="0">
-                        <a:latin typeface="Calibri" charset="0"/>
-                        <a:ea typeface="Calibri" charset="0"/>
-                        <a:cs typeface="Calibri" charset="0"/>
-                      </a:endParaRPr>
-                    </a:p>
-                  </a:txBody>
-                  <a:tcPr marL="82296" marR="82296" marT="82296" marB="82296" anchor="ctr">
-                    <a:lnL w="12700" cap="flat" cmpd="sng" algn="ctr">
-                      <a:solidFill>
-                        <a:srgbClr val="E2DCEC"/>
-                      </a:solidFill>
-                      <a:prstDash val="solid"/>
-                      <a:round/>
-                      <a:headEnd type="none" w="med" len="med"/>
-                      <a:tailEnd type="none" w="med" len="med"/>
-                    </a:lnL>
-                    <a:lnR w="12700" cap="flat" cmpd="sng" algn="ctr">
-                      <a:solidFill>
-                        <a:srgbClr val="E2DCEC"/>
-                      </a:solidFill>
-                      <a:prstDash val="solid"/>
-                      <a:round/>
-                      <a:headEnd type="none" w="med" len="med"/>
-                      <a:tailEnd type="none" w="med" len="med"/>
-                    </a:lnR>
-                    <a:lnT w="12700" cap="flat" cmpd="sng" algn="ctr">
-                      <a:solidFill>
-                        <a:srgbClr val="E2DCEC"/>
-                      </a:solidFill>
-                      <a:prstDash val="solid"/>
-                      <a:round/>
-                      <a:headEnd type="none" w="med" len="med"/>
-                      <a:tailEnd type="none" w="med" len="med"/>
-                    </a:lnT>
-                    <a:lnB w="12700" cap="flat" cmpd="sng" algn="ctr">
-                      <a:solidFill>
-                        <a:srgbClr val="E2DCEC"/>
-                      </a:solidFill>
-                      <a:prstDash val="solid"/>
-                      <a:round/>
-                      <a:headEnd type="none" w="med" len="med"/>
-                      <a:tailEnd type="none" w="med" len="med"/>
-                    </a:lnB>
-                    <a:solidFill>
-                      <a:srgbClr val="FFFFFF"/>
-                    </a:solidFill>
-                  </a:tcPr>
-                </a:tc>
-              </a:tr>
-              <a:tr h="402336">
-                <a:tc>
-                  <a:txBody>
-                    <a:bodyPr/>
-                    <a:lstStyle/>
-                    <a:p>
-                      <a:pPr indent="0" marL="0">
-                        <a:buNone/>
-                      </a:pPr>
-                      <a:r>
-                        <a:rPr lang="en-US" sz="1150" b="1" dirty="0">
-                          <a:solidFill>
-                            <a:srgbClr val="6E6484"/>
-                          </a:solidFill>
-                          <a:latin typeface="Calibri" pitchFamily="34" charset="0"/>
-                          <a:ea typeface="Calibri" pitchFamily="34" charset="-122"/>
-                          <a:cs typeface="Calibri" pitchFamily="34" charset="-120"/>
-                        </a:rPr>
-                        <a:t>What it costs us</a:t>
-                      </a:r>
-                      <a:endParaRPr lang="en-US" sz="1150" dirty="0">
-                        <a:latin typeface="Calibri" charset="0"/>
-                        <a:ea typeface="Calibri" charset="0"/>
-                        <a:cs typeface="Calibri" charset="0"/>
-                      </a:endParaRPr>
-                    </a:p>
-                  </a:txBody>
-                  <a:tcPr marL="82296" marR="82296" marT="82296" marB="82296" anchor="ctr">
-                    <a:lnL w="12700" cap="flat" cmpd="sng" algn="ctr">
-                      <a:solidFill>
-                        <a:srgbClr val="E2DCEC"/>
-                      </a:solidFill>
-                      <a:prstDash val="solid"/>
-                      <a:round/>
-                      <a:headEnd type="none" w="med" len="med"/>
-                      <a:tailEnd type="none" w="med" len="med"/>
-                    </a:lnL>
-                    <a:lnR w="12700" cap="flat" cmpd="sng" algn="ctr">
-                      <a:solidFill>
-                        <a:srgbClr val="E2DCEC"/>
-                      </a:solidFill>
-                      <a:prstDash val="solid"/>
-                      <a:round/>
-                      <a:headEnd type="none" w="med" len="med"/>
-                      <a:tailEnd type="none" w="med" len="med"/>
-                    </a:lnR>
-                    <a:lnT w="12700" cap="flat" cmpd="sng" algn="ctr">
-                      <a:solidFill>
-                        <a:srgbClr val="E2DCEC"/>
-                      </a:solidFill>
-                      <a:prstDash val="solid"/>
-                      <a:round/>
-                      <a:headEnd type="none" w="med" len="med"/>
-                      <a:tailEnd type="none" w="med" len="med"/>
-                    </a:lnT>
-                    <a:lnB w="12700" cap="flat" cmpd="sng" algn="ctr">
-                      <a:solidFill>
-                        <a:srgbClr val="E2DCEC"/>
-                      </a:solidFill>
-                      <a:prstDash val="solid"/>
-                      <a:round/>
-                      <a:headEnd type="none" w="med" len="med"/>
-                      <a:tailEnd type="none" w="med" len="med"/>
-                    </a:lnB>
-                    <a:solidFill>
-                      <a:srgbClr val="FFFFFF"/>
-                    </a:solidFill>
-                  </a:tcPr>
-                </a:tc>
-                <a:tc>
-                  <a:txBody>
-                    <a:bodyPr/>
-                    <a:lstStyle/>
-                    <a:p>
-                      <a:pPr indent="0" marL="0">
-                        <a:buNone/>
-                      </a:pPr>
-                      <a:r>
-                        <a:rPr lang="en-US" sz="1250" dirty="0">
-                          <a:solidFill>
-                            <a:srgbClr val="2F2740"/>
-                          </a:solidFill>
-                          <a:latin typeface="Calibri" pitchFamily="34" charset="0"/>
-                          <a:ea typeface="Calibri" pitchFamily="34" charset="-122"/>
-                          <a:cs typeface="Calibri" pitchFamily="34" charset="-120"/>
-                        </a:rPr>
-                        <a:t>Low</a:t>
-                      </a:r>
-                      <a:endParaRPr lang="en-US" sz="1250" dirty="0">
-                        <a:latin typeface="Calibri" charset="0"/>
-                        <a:ea typeface="Calibri" charset="0"/>
-                        <a:cs typeface="Calibri" charset="0"/>
-                      </a:endParaRPr>
-                    </a:p>
-                  </a:txBody>
-                  <a:tcPr marL="82296" marR="82296" marT="82296" marB="82296" anchor="ctr">
-                    <a:lnL w="12700" cap="flat" cmpd="sng" algn="ctr">
-                      <a:solidFill>
-                        <a:srgbClr val="E2DCEC"/>
-                      </a:solidFill>
-                      <a:prstDash val="solid"/>
-                      <a:round/>
-                      <a:headEnd type="none" w="med" len="med"/>
-                      <a:tailEnd type="none" w="med" len="med"/>
-                    </a:lnL>
-                    <a:lnR w="12700" cap="flat" cmpd="sng" algn="ctr">
-                      <a:solidFill>
-                        <a:srgbClr val="E2DCEC"/>
-                      </a:solidFill>
-                      <a:prstDash val="solid"/>
-                      <a:round/>
-                      <a:headEnd type="none" w="med" len="med"/>
-                      <a:tailEnd type="none" w="med" len="med"/>
-                    </a:lnR>
-                    <a:lnT w="12700" cap="flat" cmpd="sng" algn="ctr">
-                      <a:solidFill>
-                        <a:srgbClr val="E2DCEC"/>
-                      </a:solidFill>
-                      <a:prstDash val="solid"/>
-                      <a:round/>
-                      <a:headEnd type="none" w="med" len="med"/>
-                      <a:tailEnd type="none" w="med" len="med"/>
-                    </a:lnT>
-                    <a:lnB w="12700" cap="flat" cmpd="sng" algn="ctr">
-                      <a:solidFill>
-                        <a:srgbClr val="E2DCEC"/>
-                      </a:solidFill>
-                      <a:prstDash val="solid"/>
-                      <a:round/>
-                      <a:headEnd type="none" w="med" len="med"/>
-                      <a:tailEnd type="none" w="med" len="med"/>
-                    </a:lnB>
-                    <a:solidFill>
-                      <a:srgbClr val="FFFFFF"/>
-                    </a:solidFill>
-                  </a:tcPr>
-                </a:tc>
-                <a:tc>
-                  <a:txBody>
-                    <a:bodyPr/>
-                    <a:lstStyle/>
-                    <a:p>
-                      <a:pPr indent="0" marL="0">
-                        <a:buNone/>
-                      </a:pPr>
-                      <a:r>
-                        <a:rPr lang="en-US" sz="1250" b="1" dirty="0">
-                          <a:solidFill>
-                            <a:srgbClr val="19102A"/>
-                          </a:solidFill>
-                          <a:latin typeface="Calibri" pitchFamily="34" charset="0"/>
-                          <a:ea typeface="Calibri" pitchFamily="34" charset="-122"/>
-                          <a:cs typeface="Calibri" pitchFamily="34" charset="-120"/>
-                        </a:rPr>
-                        <a:t>Lower per peso of balance</a:t>
-                      </a:r>
-                      <a:endParaRPr lang="en-US" sz="1250" dirty="0">
+                      <a:endParaRPr lang="en-US" sz="1100" dirty="0">
                         <a:latin typeface="Calibri" charset="0"/>
                         <a:ea typeface="Calibri" charset="0"/>
                         <a:cs typeface="Calibri" charset="0"/>
@@ -12144,14 +11782,125 @@
       </p:graphicFrame>
       <p:sp>
         <p:nvSpPr>
-          <p:cNvPr id="6" name="Shape 3"/>
+          <p:cNvPr id="7" name="Shape 4"/>
           <p:cNvSpPr/>
           <p:nvPr/>
         </p:nvSpPr>
         <p:spPr>
           <a:xfrm>
-            <a:off x="7360920" y="1783080"/>
-            <a:ext cx="4279392" cy="3977640"/>
+            <a:off x="566928" y="3977640"/>
+            <a:ext cx="5760720" cy="1737360"/>
+          </a:xfrm>
+          <a:prstGeom prst="roundRect">
+            <a:avLst>
+              <a:gd name="adj" fmla="val 3158"/>
+            </a:avLst>
+          </a:prstGeom>
+          <a:solidFill>
+            <a:srgbClr val="F3E8FD"/>
+          </a:solidFill>
+          <a:ln w="12700">
+            <a:solidFill>
+              <a:srgbClr val="E2DCEC"/>
+            </a:solidFill>
+            <a:prstDash val="solid"/>
+          </a:ln>
+        </p:spPr>
+      </p:sp>
+      <p:sp>
+        <p:nvSpPr>
+          <p:cNvPr id="8" name="Text 5"/>
+          <p:cNvSpPr txBox="1"/>
+          <p:nvPr/>
+        </p:nvSpPr>
+        <p:spPr>
+          <a:xfrm>
+            <a:off x="841248" y="4160520"/>
+            <a:ext cx="5257800" cy="402336"/>
+          </a:xfrm>
+          <a:prstGeom prst="rect">
+            <a:avLst/>
+          </a:prstGeom>
+          <a:noFill/>
+          <a:ln/>
+        </p:spPr>
+        <p:txBody>
+          <a:bodyPr wrap="square" lIns="0" tIns="0" rIns="0" bIns="0" rtlCol="0" anchor="ctr"/>
+          <a:lstStyle/>
+          <a:p>
+            <a:pPr indent="0" marL="0">
+              <a:lnSpc>
+                <a:spcPts val="1800"/>
+              </a:lnSpc>
+              <a:buNone/>
+            </a:pPr>
+            <a:r>
+              <a:rPr lang="en-US" sz="1350" b="1" dirty="0">
+                <a:solidFill>
+                  <a:srgbClr val="19102A"/>
+                </a:solidFill>
+                <a:latin typeface="Arial" pitchFamily="34" charset="0"/>
+                <a:ea typeface="Arial" pitchFamily="34" charset="-122"/>
+                <a:cs typeface="Arial" pitchFamily="34" charset="-120"/>
+              </a:rPr>
+              <a:t>The tiering, the cap and the behavioural gate are already built.</a:t>
+            </a:r>
+            <a:endParaRPr lang="en-US" sz="1350" dirty="0"/>
+          </a:p>
+        </p:txBody>
+      </p:sp>
+      <p:sp>
+        <p:nvSpPr>
+          <p:cNvPr id="9" name="Text 6"/>
+          <p:cNvSpPr txBox="1"/>
+          <p:nvPr/>
+        </p:nvSpPr>
+        <p:spPr>
+          <a:xfrm>
+            <a:off x="841248" y="4590288"/>
+            <a:ext cx="5257800" cy="1005840"/>
+          </a:xfrm>
+          <a:prstGeom prst="rect">
+            <a:avLst/>
+          </a:prstGeom>
+          <a:noFill/>
+          <a:ln/>
+        </p:spPr>
+        <p:txBody>
+          <a:bodyPr wrap="square" lIns="0" tIns="0" rIns="0" bIns="0" rtlCol="0" anchor="ctr"/>
+          <a:lstStyle/>
+          <a:p>
+            <a:pPr indent="0" marL="0">
+              <a:lnSpc>
+                <a:spcPts val="1700"/>
+              </a:lnSpc>
+              <a:buNone/>
+            </a:pPr>
+            <a:r>
+              <a:rPr lang="en-US" sz="1250" dirty="0">
+                <a:solidFill>
+                  <a:srgbClr val="2F2740"/>
+                </a:solidFill>
+                <a:latin typeface="Calibri" pitchFamily="34" charset="0"/>
+                <a:ea typeface="Calibri" pitchFamily="34" charset="-122"/>
+                <a:cs typeface="Calibri" pitchFamily="34" charset="-120"/>
+              </a:rPr>
+              <a:t>The base tier already sits at the risk-free rate, and Turbo was already cut from 15% to 13% in January. The unsolved problem is not whether to have a premium tier. It is which gate and which cap.</a:t>
+            </a:r>
+            <a:endParaRPr lang="en-US" sz="1250" dirty="0"/>
+          </a:p>
+        </p:txBody>
+      </p:sp>
+      <p:sp>
+        <p:nvSpPr>
+          <p:cNvPr id="10" name="Shape 7"/>
+          <p:cNvSpPr/>
+          <p:nvPr/>
+        </p:nvSpPr>
+        <p:spPr>
+          <a:xfrm>
+            <a:off x="6537960" y="1737360"/>
+            <a:ext cx="5102352" cy="3977640"/>
           </a:xfrm>
           <a:prstGeom prst="roundRect">
             <a:avLst>
@@ -12171,14 +11920,14 @@
       </p:sp>
       <p:sp>
         <p:nvSpPr>
-          <p:cNvPr id="7" name="Text 4"/>
-          <p:cNvSpPr txBox="1"/>
-          <p:nvPr/>
-        </p:nvSpPr>
-        <p:spPr>
-          <a:xfrm>
-            <a:off x="7616952" y="1965960"/>
-            <a:ext cx="3840480" cy="292608"/>
+          <p:cNvPr id="11" name="Text 8"/>
+          <p:cNvSpPr txBox="1"/>
+          <p:nvPr/>
+        </p:nvSpPr>
+        <p:spPr>
+          <a:xfrm>
+            <a:off x="6793992" y="1920240"/>
+            <a:ext cx="4572000" cy="274320"/>
           </a:xfrm>
           <a:prstGeom prst="rect">
             <a:avLst/>
@@ -12202,7 +11951,7 @@
                 <a:ea typeface="Arial" pitchFamily="34" charset="-122"/>
                 <a:cs typeface="Arial" pitchFamily="34" charset="-120"/>
               </a:rPr>
-              <a:t>Four design decisions</a:t>
+              <a:t>What I would change</a:t>
             </a:r>
             <a:endParaRPr lang="en-US" sz="1500" dirty="0"/>
           </a:p>
@@ -12210,13 +11959,13 @@
       </p:sp>
       <p:sp>
         <p:nvSpPr>
-          <p:cNvPr id="8" name="Text 5"/>
-          <p:cNvSpPr txBox="1"/>
-          <p:nvPr/>
-        </p:nvSpPr>
-        <p:spPr>
-          <a:xfrm>
-            <a:off x="7616952" y="2377440"/>
+          <p:cNvPr id="12" name="Text 9"/>
+          <p:cNvSpPr txBox="1"/>
+          <p:nvPr/>
+        </p:nvSpPr>
+        <p:spPr>
+          <a:xfrm>
+            <a:off x="6793992" y="2331720"/>
             <a:ext cx="274320" cy="274320"/>
           </a:xfrm>
           <a:prstGeom prst="rect">
@@ -12249,30 +11998,30 @@
       </p:sp>
       <p:sp>
         <p:nvSpPr>
-          <p:cNvPr id="9" name="Text 6"/>
-          <p:cNvSpPr txBox="1"/>
-          <p:nvPr/>
-        </p:nvSpPr>
-        <p:spPr>
-          <a:xfrm>
-            <a:off x="7936992" y="2359152"/>
-            <a:ext cx="3566160" cy="274320"/>
-          </a:xfrm>
-          <a:prstGeom prst="rect">
-            <a:avLst/>
-          </a:prstGeom>
-          <a:noFill/>
-          <a:ln/>
-        </p:spPr>
-        <p:txBody>
-          <a:bodyPr wrap="square" lIns="0" tIns="0" rIns="0" bIns="0" rtlCol="0" anchor="ctr"/>
-          <a:lstStyle/>
-          <a:p>
-            <a:pPr indent="0" marL="0">
-              <a:buNone/>
-            </a:pPr>
-            <a:r>
-              <a:rPr lang="en-US" sz="1250" b="1" dirty="0">
+          <p:cNvPr id="13" name="Text 10"/>
+          <p:cNvSpPr txBox="1"/>
+          <p:nvPr/>
+        </p:nvSpPr>
+        <p:spPr>
+          <a:xfrm>
+            <a:off x="7114032" y="2313432"/>
+            <a:ext cx="4206240" cy="274320"/>
+          </a:xfrm>
+          <a:prstGeom prst="rect">
+            <a:avLst/>
+          </a:prstGeom>
+          <a:noFill/>
+          <a:ln/>
+        </p:spPr>
+        <p:txBody>
+          <a:bodyPr wrap="square" lIns="0" tIns="0" rIns="0" bIns="0" rtlCol="0" anchor="ctr"/>
+          <a:lstStyle/>
+          <a:p>
+            <a:pPr indent="0" marL="0">
+              <a:buNone/>
+            </a:pPr>
+            <a:r>
+              <a:rPr lang="en-US" sz="1300" b="1" dirty="0">
                 <a:solidFill>
                   <a:srgbClr val="19102A"/>
                 </a:solidFill>
@@ -12280,22 +12029,22 @@
                 <a:ea typeface="Arial" pitchFamily="34" charset="-122"/>
                 <a:cs typeface="Arial" pitchFamily="34" charset="-120"/>
               </a:rPr>
-              <a:t>Two tiers, not five.</a:t>
-            </a:r>
-            <a:endParaRPr lang="en-US" sz="1250" dirty="0"/>
-          </a:p>
-        </p:txBody>
-      </p:sp>
-      <p:sp>
-        <p:nvSpPr>
-          <p:cNvPr id="10" name="Text 7"/>
-          <p:cNvSpPr txBox="1"/>
-          <p:nvPr/>
-        </p:nvSpPr>
-        <p:spPr>
-          <a:xfrm>
-            <a:off x="7936992" y="2633472"/>
-            <a:ext cx="3566160" cy="457200"/>
+              <a:t>Change the gate.</a:t>
+            </a:r>
+            <a:endParaRPr lang="en-US" sz="1300" dirty="0"/>
+          </a:p>
+        </p:txBody>
+      </p:sp>
+      <p:sp>
+        <p:nvSpPr>
+          <p:cNvPr id="14" name="Text 11"/>
+          <p:cNvSpPr txBox="1"/>
+          <p:nvPr/>
+        </p:nvSpPr>
+        <p:spPr>
+          <a:xfrm>
+            <a:off x="7114032" y="2606040"/>
+            <a:ext cx="4206240" cy="822960"/>
           </a:xfrm>
           <a:prstGeom prst="rect">
             <a:avLst/>
@@ -12322,7 +12071,7 @@
                 <a:ea typeface="Calibri" pitchFamily="34" charset="-122"/>
                 <a:cs typeface="Calibri" pitchFamily="34" charset="-120"/>
               </a:rPr>
-              <a:t>Mass market punishes complexity. Every tier is a support call.</a:t>
+              <a:t>One card purchase a month proves the customer is alive, not that they bank with us. It is nearly costless to satisfy and carries almost no information. Gate the premium on income landing instead.</a:t>
             </a:r>
             <a:endParaRPr lang="en-US" sz="1150" dirty="0"/>
           </a:p>
@@ -12330,13 +12079,13 @@
       </p:sp>
       <p:sp>
         <p:nvSpPr>
-          <p:cNvPr id="11" name="Text 8"/>
-          <p:cNvSpPr txBox="1"/>
-          <p:nvPr/>
-        </p:nvSpPr>
-        <p:spPr>
-          <a:xfrm>
-            <a:off x="7616952" y="3200400"/>
+          <p:cNvPr id="15" name="Text 12"/>
+          <p:cNvSpPr txBox="1"/>
+          <p:nvPr/>
+        </p:nvSpPr>
+        <p:spPr>
+          <a:xfrm>
+            <a:off x="6793992" y="3447288"/>
             <a:ext cx="274320" cy="274320"/>
           </a:xfrm>
           <a:prstGeom prst="rect">
@@ -12369,30 +12118,30 @@
       </p:sp>
       <p:sp>
         <p:nvSpPr>
-          <p:cNvPr id="12" name="Text 9"/>
-          <p:cNvSpPr txBox="1"/>
-          <p:nvPr/>
-        </p:nvSpPr>
-        <p:spPr>
-          <a:xfrm>
-            <a:off x="7936992" y="3182112"/>
-            <a:ext cx="3566160" cy="274320"/>
-          </a:xfrm>
-          <a:prstGeom prst="rect">
-            <a:avLst/>
-          </a:prstGeom>
-          <a:noFill/>
-          <a:ln/>
-        </p:spPr>
-        <p:txBody>
-          <a:bodyPr wrap="square" lIns="0" tIns="0" rIns="0" bIns="0" rtlCol="0" anchor="ctr"/>
-          <a:lstStyle/>
-          <a:p>
-            <a:pPr indent="0" marL="0">
-              <a:buNone/>
-            </a:pPr>
-            <a:r>
-              <a:rPr lang="en-US" sz="1250" b="1" dirty="0">
+          <p:cNvPr id="16" name="Text 13"/>
+          <p:cNvSpPr txBox="1"/>
+          <p:nvPr/>
+        </p:nvSpPr>
+        <p:spPr>
+          <a:xfrm>
+            <a:off x="7114032" y="3429000"/>
+            <a:ext cx="4206240" cy="274320"/>
+          </a:xfrm>
+          <a:prstGeom prst="rect">
+            <a:avLst/>
+          </a:prstGeom>
+          <a:noFill/>
+          <a:ln/>
+        </p:spPr>
+        <p:txBody>
+          <a:bodyPr wrap="square" lIns="0" tIns="0" rIns="0" bIns="0" rtlCol="0" anchor="ctr"/>
+          <a:lstStyle/>
+          <a:p>
+            <a:pPr indent="0" marL="0">
+              <a:buNone/>
+            </a:pPr>
+            <a:r>
+              <a:rPr lang="en-US" sz="1300" b="1" dirty="0">
                 <a:solidFill>
                   <a:srgbClr val="19102A"/>
                 </a:solidFill>
@@ -12400,22 +12149,22 @@
                 <a:ea typeface="Arial" pitchFamily="34" charset="-122"/>
                 <a:cs typeface="Arial" pitchFamily="34" charset="-120"/>
               </a:rPr>
-              <a:t>The premium is a behaviour, not a balance.</a:t>
-            </a:r>
-            <a:endParaRPr lang="en-US" sz="1250" dirty="0"/>
-          </a:p>
-        </p:txBody>
-      </p:sp>
-      <p:sp>
-        <p:nvSpPr>
-          <p:cNvPr id="13" name="Text 10"/>
-          <p:cNvSpPr txBox="1"/>
-          <p:nvPr/>
-        </p:nvSpPr>
-        <p:spPr>
-          <a:xfrm>
-            <a:off x="7936992" y="3456432"/>
-            <a:ext cx="3566160" cy="457200"/>
+              <a:t>Change the cap.</a:t>
+            </a:r>
+            <a:endParaRPr lang="en-US" sz="1300" dirty="0"/>
+          </a:p>
+        </p:txBody>
+      </p:sp>
+      <p:sp>
+        <p:nvSpPr>
+          <p:cNvPr id="17" name="Text 14"/>
+          <p:cNvSpPr txBox="1"/>
+          <p:nvPr/>
+        </p:nvSpPr>
+        <p:spPr>
+          <a:xfrm>
+            <a:off x="7114032" y="3721608"/>
+            <a:ext cx="4206240" cy="822960"/>
           </a:xfrm>
           <a:prstGeom prst="rect">
             <a:avLst/>
@@ -12442,7 +12191,7 @@
                 <a:ea typeface="Calibri" pitchFamily="34" charset="-122"/>
                 <a:cs typeface="Calibri" pitchFamily="34" charset="-120"/>
               </a:rPr>
-              <a:t>We pay up only for money that arrives with data behind it.</a:t>
+              <a:t>A flat MX$25,000 gives every customer an identical yield subsidy regardless of what they bring. Scale the cap with income deposited — roughly one month of it.</a:t>
             </a:r>
             <a:endParaRPr lang="en-US" sz="1150" dirty="0"/>
           </a:p>
@@ -12450,13 +12199,13 @@
       </p:sp>
       <p:sp>
         <p:nvSpPr>
-          <p:cNvPr id="14" name="Text 11"/>
-          <p:cNvSpPr txBox="1"/>
-          <p:nvPr/>
-        </p:nvSpPr>
-        <p:spPr>
-          <a:xfrm>
-            <a:off x="7616952" y="4023360"/>
+          <p:cNvPr id="18" name="Text 15"/>
+          <p:cNvSpPr txBox="1"/>
+          <p:nvPr/>
+        </p:nvSpPr>
+        <p:spPr>
+          <a:xfrm>
+            <a:off x="6793992" y="4562856"/>
             <a:ext cx="274320" cy="274320"/>
           </a:xfrm>
           <a:prstGeom prst="rect">
@@ -12489,30 +12238,30 @@
       </p:sp>
       <p:sp>
         <p:nvSpPr>
-          <p:cNvPr id="15" name="Text 12"/>
-          <p:cNvSpPr txBox="1"/>
-          <p:nvPr/>
-        </p:nvSpPr>
-        <p:spPr>
-          <a:xfrm>
-            <a:off x="7936992" y="4005072"/>
-            <a:ext cx="3566160" cy="274320"/>
-          </a:xfrm>
-          <a:prstGeom prst="rect">
-            <a:avLst/>
-          </a:prstGeom>
-          <a:noFill/>
-          <a:ln/>
-        </p:spPr>
-        <p:txBody>
-          <a:bodyPr wrap="square" lIns="0" tIns="0" rIns="0" bIns="0" rtlCol="0" anchor="ctr"/>
-          <a:lstStyle/>
-          <a:p>
-            <a:pPr indent="0" marL="0">
-              <a:buNone/>
-            </a:pPr>
-            <a:r>
-              <a:rPr lang="en-US" sz="1250" b="1" dirty="0">
+          <p:cNvPr id="19" name="Text 16"/>
+          <p:cNvSpPr txBox="1"/>
+          <p:nvPr/>
+        </p:nvSpPr>
+        <p:spPr>
+          <a:xfrm>
+            <a:off x="7114032" y="4544568"/>
+            <a:ext cx="4206240" cy="274320"/>
+          </a:xfrm>
+          <a:prstGeom prst="rect">
+            <a:avLst/>
+          </a:prstGeom>
+          <a:noFill/>
+          <a:ln/>
+        </p:spPr>
+        <p:txBody>
+          <a:bodyPr wrap="square" lIns="0" tIns="0" rIns="0" bIns="0" rtlCol="0" anchor="ctr"/>
+          <a:lstStyle/>
+          <a:p>
+            <a:pPr indent="0" marL="0">
+              <a:buNone/>
+            </a:pPr>
+            <a:r>
+              <a:rPr lang="en-US" sz="1300" b="1" dirty="0">
                 <a:solidFill>
                   <a:srgbClr val="19102A"/>
                 </a:solidFill>
@@ -12520,22 +12269,22 @@
                 <a:ea typeface="Arial" pitchFamily="34" charset="-122"/>
                 <a:cs typeface="Arial" pitchFamily="34" charset="-120"/>
               </a:rPr>
-              <a:t>Cap the premium balance.</a:t>
-            </a:r>
-            <a:endParaRPr lang="en-US" sz="1250" dirty="0"/>
-          </a:p>
-        </p:txBody>
-      </p:sp>
-      <p:sp>
-        <p:nvSpPr>
-          <p:cNvPr id="16" name="Text 13"/>
-          <p:cNvSpPr txBox="1"/>
-          <p:nvPr/>
-        </p:nvSpPr>
-        <p:spPr>
-          <a:xfrm>
-            <a:off x="7936992" y="4279392"/>
-            <a:ext cx="3566160" cy="457200"/>
+              <a:t>Change the quote.</a:t>
+            </a:r>
+            <a:endParaRPr lang="en-US" sz="1300" dirty="0"/>
+          </a:p>
+        </p:txBody>
+      </p:sp>
+      <p:sp>
+        <p:nvSpPr>
+          <p:cNvPr id="20" name="Text 17"/>
+          <p:cNvSpPr txBox="1"/>
+          <p:nvPr/>
+        </p:nvSpPr>
+        <p:spPr>
+          <a:xfrm>
+            <a:off x="7114032" y="4837176"/>
+            <a:ext cx="4206240" cy="822960"/>
           </a:xfrm>
           <a:prstGeom prst="rect">
             <a:avLst/>
@@ -12562,7 +12311,7 @@
                 <a:ea typeface="Calibri" pitchFamily="34" charset="-122"/>
                 <a:cs typeface="Calibri" pitchFamily="34" charset="-120"/>
               </a:rPr>
-              <a:t>We are buying the relationship, not the treasury balance.</a:t>
+              <a:t>“13% fija” forces us to announce every cut. January’s produced “ganarás menos por tus ahorros” and “pésimas noticias para clientes Nu”. A spread over CETES reprices silently as Banxico moves.</a:t>
             </a:r>
             <a:endParaRPr lang="en-US" sz="1150" dirty="0"/>
           </a:p>
@@ -12570,158 +12319,38 @@
       </p:sp>
       <p:sp>
         <p:nvSpPr>
-          <p:cNvPr id="17" name="Text 14"/>
-          <p:cNvSpPr txBox="1"/>
-          <p:nvPr/>
-        </p:nvSpPr>
-        <p:spPr>
-          <a:xfrm>
-            <a:off x="7616952" y="4846320"/>
-            <a:ext cx="274320" cy="274320"/>
-          </a:xfrm>
-          <a:prstGeom prst="rect">
-            <a:avLst/>
-          </a:prstGeom>
-          <a:noFill/>
-          <a:ln/>
-        </p:spPr>
-        <p:txBody>
-          <a:bodyPr wrap="square" lIns="0" tIns="0" rIns="0" bIns="0" rtlCol="0" anchor="ctr"/>
-          <a:lstStyle/>
-          <a:p>
-            <a:pPr indent="0" marL="0">
-              <a:buNone/>
-            </a:pPr>
-            <a:r>
-              <a:rPr lang="en-US" sz="1300" b="1" dirty="0">
-                <a:solidFill>
-                  <a:srgbClr val="820AD1"/>
-                </a:solidFill>
-                <a:latin typeface="Arial" pitchFamily="34" charset="0"/>
-                <a:ea typeface="Arial" pitchFamily="34" charset="-122"/>
-                <a:cs typeface="Arial" pitchFamily="34" charset="-120"/>
-              </a:rPr>
-              <a:t>4</a:t>
-            </a:r>
-            <a:endParaRPr lang="en-US" sz="1300" dirty="0"/>
-          </a:p>
-        </p:txBody>
-      </p:sp>
-      <p:sp>
-        <p:nvSpPr>
-          <p:cNvPr id="18" name="Text 15"/>
-          <p:cNvSpPr txBox="1"/>
-          <p:nvPr/>
-        </p:nvSpPr>
-        <p:spPr>
-          <a:xfrm>
-            <a:off x="7936992" y="4828032"/>
-            <a:ext cx="3566160" cy="274320"/>
-          </a:xfrm>
-          <a:prstGeom prst="rect">
-            <a:avLst/>
-          </a:prstGeom>
-          <a:noFill/>
-          <a:ln/>
-        </p:spPr>
-        <p:txBody>
-          <a:bodyPr wrap="square" lIns="0" tIns="0" rIns="0" bIns="0" rtlCol="0" anchor="ctr"/>
-          <a:lstStyle/>
-          <a:p>
-            <a:pPr indent="0" marL="0">
-              <a:buNone/>
-            </a:pPr>
-            <a:r>
-              <a:rPr lang="en-US" sz="1250" b="1" dirty="0">
-                <a:solidFill>
-                  <a:srgbClr val="19102A"/>
-                </a:solidFill>
-                <a:latin typeface="Arial" pitchFamily="34" charset="0"/>
-                <a:ea typeface="Arial" pitchFamily="34" charset="-122"/>
-                <a:cs typeface="Arial" pitchFamily="34" charset="-120"/>
-              </a:rPr>
-              <a:t>One tier, two doors.</a:t>
-            </a:r>
-            <a:endParaRPr lang="en-US" sz="1250" dirty="0"/>
-          </a:p>
-        </p:txBody>
-      </p:sp>
-      <p:sp>
-        <p:nvSpPr>
-          <p:cNvPr id="19" name="Text 16"/>
-          <p:cNvSpPr txBox="1"/>
-          <p:nvPr/>
-        </p:nvSpPr>
-        <p:spPr>
-          <a:xfrm>
-            <a:off x="7936992" y="5102352"/>
-            <a:ext cx="3566160" cy="457200"/>
-          </a:xfrm>
-          <a:prstGeom prst="rect">
-            <a:avLst/>
-          </a:prstGeom>
-          <a:noFill/>
-          <a:ln/>
-        </p:spPr>
-        <p:txBody>
-          <a:bodyPr wrap="square" lIns="0" tIns="0" rIns="0" bIns="0" rtlCol="0" anchor="ctr"/>
-          <a:lstStyle/>
-          <a:p>
-            <a:pPr indent="0" marL="0">
-              <a:lnSpc>
-                <a:spcPts val="1500"/>
-              </a:lnSpc>
-              <a:buNone/>
-            </a:pPr>
-            <a:r>
-              <a:rPr lang="en-US" sz="1150" dirty="0">
-                <a:solidFill>
-                  <a:srgbClr val="2F2740"/>
+          <p:cNvPr id="21" name="Text 18"/>
+          <p:cNvSpPr txBox="1"/>
+          <p:nvPr/>
+        </p:nvSpPr>
+        <p:spPr>
+          <a:xfrm>
+            <a:off x="566928" y="6382512"/>
+            <a:ext cx="11057839" cy="274320"/>
+          </a:xfrm>
+          <a:prstGeom prst="rect">
+            <a:avLst/>
+          </a:prstGeom>
+          <a:noFill/>
+          <a:ln/>
+        </p:spPr>
+        <p:txBody>
+          <a:bodyPr wrap="square" lIns="0" tIns="0" rIns="0" bIns="0" rtlCol="0" anchor="ctr"/>
+          <a:lstStyle/>
+          <a:p>
+            <a:pPr indent="0" marL="0">
+              <a:buNone/>
+            </a:pPr>
+            <a:r>
+              <a:rPr lang="en-US" sz="950" i="1" dirty="0">
+                <a:solidFill>
+                  <a:srgbClr val="6E6484"/>
                 </a:solidFill>
                 <a:latin typeface="Calibri" pitchFamily="34" charset="0"/>
                 <a:ea typeface="Calibri" pitchFamily="34" charset="-122"/>
                 <a:cs typeface="Calibri" pitchFamily="34" charset="-120"/>
               </a:rPr>
-              <a:t>Documented and observed income reach identical terms.</a:t>
-            </a:r>
-            <a:endParaRPr lang="en-US" sz="1150" dirty="0"/>
-          </a:p>
-        </p:txBody>
-      </p:sp>
-      <p:sp>
-        <p:nvSpPr>
-          <p:cNvPr id="20" name="Text 17"/>
-          <p:cNvSpPr txBox="1"/>
-          <p:nvPr/>
-        </p:nvSpPr>
-        <p:spPr>
-          <a:xfrm>
-            <a:off x="566928" y="6382512"/>
-            <a:ext cx="11057839" cy="274320"/>
-          </a:xfrm>
-          <a:prstGeom prst="rect">
-            <a:avLst/>
-          </a:prstGeom>
-          <a:noFill/>
-          <a:ln/>
-        </p:spPr>
-        <p:txBody>
-          <a:bodyPr wrap="square" lIns="0" tIns="0" rIns="0" bIns="0" rtlCol="0" anchor="ctr"/>
-          <a:lstStyle/>
-          <a:p>
-            <a:pPr indent="0" marL="0">
-              <a:buNone/>
-            </a:pPr>
-            <a:r>
-              <a:rPr lang="en-US" sz="950" i="1" dirty="0">
-                <a:solidFill>
-                  <a:srgbClr val="6E6484"/>
-                </a:solidFill>
-                <a:latin typeface="Calibri" pitchFamily="34" charset="0"/>
-                <a:ea typeface="Calibri" pitchFamily="34" charset="-122"/>
-                <a:cs typeface="Calibri" pitchFamily="34" charset="-120"/>
-              </a:rPr>
-              <a:t>“One tier, two doors” is the inclusion argument and the fairness argument at once: if the informal tier is not a lower tier, there is no disparate outcome to explain.</a:t>
+              <a:t>One tier, two doors: documented income and observed income must reach identical terms — which is the inclusion argument and the fairness argument at once.</a:t>
             </a:r>
             <a:endParaRPr lang="en-US" sz="950" dirty="0"/>
           </a:p>
@@ -13960,7 +13589,7 @@
                 <a:ea typeface="Calibri" pitchFamily="34" charset="-122"/>
                 <a:cs typeface="Calibri" pitchFamily="34" charset="-120"/>
               </a:rPr>
-              <a:t>“CETES + 4.00%”, not “10.49%”. As Banxico cuts, funding cost falls automatically and there is never a “Nu cut your rate” headline — because we did not.</a:t>
+              <a:t>Today it is “13% fija”, so every cut must be announced — January’s produced “ganarás menos por tus ahorros”. Quoted against CETES, funding cost falls as Banxico moves, with no headline.</a:t>
             </a:r>
             <a:endParaRPr lang="en-US" sz="1150" dirty="0"/>
           </a:p>
@@ -14061,7 +13690,7 @@
                 <a:ea typeface="Arial" pitchFamily="34" charset="-122"/>
                 <a:cs typeface="Arial" pitchFamily="34" charset="-120"/>
               </a:rPr>
-              <a:t>Price the relationship, not the balance.</a:t>
+              <a:t>Fix the gate, not the size of the premium.</a:t>
             </a:r>
             <a:endParaRPr lang="en-US" sz="1350" dirty="0"/>
           </a:p>
@@ -14103,7 +13732,7 @@
                 <a:ea typeface="Calibri" pitchFamily="34" charset="-122"/>
                 <a:cs typeface="Calibri" pitchFamily="34" charset="-120"/>
               </a:rPr>
-              <a:t>The premium requires income landing and is capped. We pay up only for money that brings data and stickiness with it.</a:t>
+              <a:t>Further cuts have diminishing returns and real brand cost. Re-point the 13% at income landing rather than at one card purchase a month, and it buys a relationship instead of a pulse.</a:t>
             </a:r>
             <a:endParaRPr lang="en-US" sz="1150" dirty="0"/>
           </a:p>

</xml_diff>

<commit_message>
Ground the alignment and pricing sections in prior experiment practice
Section 2.2 now leads with a shared-metric mechanism rather than a framework: a
launch criterion sitting downstream of every team involved, which is how alignment
gets built without authority. Adds a sixth move on converting roadmap disagreements
into test designs with a guardrail the other team chooses.

Slide 7 replaces a data wishlist with an actual test design - randomisation unit,
arms, primary metrics, guardrail, acceptance criterion, and pre-registered MDE.

Slide 10 states the counterfactual mechanism precisely and carries the transferable
finding, which is about exposure timing rather than exposure itself.

Adds a Tala evidence note covering what is safe to present and what must stay out,
since the source material is confidential and Nubank is a competitor.

Co-Authored-By: Claude Opus 5 <noreply@anthropic.com>
Claude-Session: https://claude.ai/code/session_01W3HQLXSfDsZKWSgdamaReC
</commit_message>
<xml_diff>
--- a/deck/Core_Mexico_Business_Case.pptx
+++ b/deck/Core_Mexico_Business_Case.pptx
@@ -3532,7 +3532,7 @@
                 <a:ea typeface="Calibri" pitchFamily="34" charset="-122"/>
                 <a:cs typeface="Calibri" pitchFamily="34" charset="-120"/>
               </a:rPr>
-              <a:t>Show our income estimate back, with the reasoning and an appeal path, before we price anyone on it.</a:t>
+              <a:t>Score the customer as if they had repaid in full and on time — then show them the limit that unlocks.</a:t>
             </a:r>
             <a:endParaRPr lang="en-US" sz="1200" dirty="0"/>
           </a:p>
@@ -3561,7 +3561,7 @@
                 <a:ea typeface="Calibri" pitchFamily="34" charset="-122"/>
                 <a:cs typeface="Calibri" pitchFamily="34" charset="-120"/>
               </a:rPr>
-              <a:t>Then show what raises the line: a counterfactual — the specific, reachable actions that unlock the next level, surfaced before the customer has to ask.</a:t>
+              <a:t>That counterfactual is the only question a capped customer actually has: what would have to be different? And the answer is a commitment, not a score.</a:t>
             </a:r>
             <a:endParaRPr lang="en-US" sz="1200" dirty="0"/>
           </a:p>
@@ -3600,7 +3600,7 @@
                 <a:ea typeface="Calibri" pitchFamily="34" charset="-122"/>
                 <a:cs typeface="Calibri" pitchFamily="34" charset="-120"/>
               </a:rPr>
-              <a:t>I shipped counterfactual line-progression at Tala México — same market, same thin-file segment — and it lifted retention 10% in the hardest and riskiest segments. Nu buys retention today with a 13% yield; progression buys it more cheaply, and unlike yield it compounds, because the customer who is climbing is the one who is repaying.</a:t>
+              <a:t>I shipped this in México, to this segment. The non-obvious finding was timing — exposing a limit too early cuts default but gives the gain back through faster repayment cycles, so expose one personalised limit, and only as the due date approaches.</a:t>
             </a:r>
             <a:endParaRPr lang="en-US" sz="950" dirty="0"/>
           </a:p>
@@ -5618,7 +5618,7 @@
                 <a:ea typeface="Calibri" pitchFamily="34" charset="-122"/>
                 <a:cs typeface="Calibri" pitchFamily="34" charset="-120"/>
               </a:rPr>
-              <a:t>Core does not own Card or GBA — so Core should own the currency. “My roadmap versus yours” cannot be won on evidence. “Which sequence makes this customer worth more” can.</a:t>
+              <a:t>Core owns neither Card nor GBA, so Core should own the currency. At Tala my launch criterion was neutral-or-positive monthly credit margin — not my feature’s engagement, not Credit’s default rate. One number downstream of all of us.</a:t>
             </a:r>
             <a:endParaRPr lang="en-US" sz="1150" dirty="0"/>
           </a:p>
@@ -6191,6 +6191,149 @@
                 <a:cs typeface="Calibri" pitchFamily="34" charset="-120"/>
               </a:rPr>
               <a:t>If Card genuinely cannot move, I ship without the card component and add it later. Shipping on time beats winning the argument.</a:t>
+            </a:r>
+            <a:endParaRPr lang="en-US" sz="1150" dirty="0"/>
+          </a:p>
+        </p:txBody>
+      </p:sp>
+      <p:sp>
+        <p:nvSpPr>
+          <p:cNvPr id="26" name="Shape 24"/>
+          <p:cNvSpPr/>
+          <p:nvPr/>
+        </p:nvSpPr>
+        <p:spPr>
+          <a:xfrm>
+            <a:off x="7973568" y="4041648"/>
+            <a:ext cx="292608" cy="292608"/>
+          </a:xfrm>
+          <a:prstGeom prst="ellipse">
+            <a:avLst/>
+          </a:prstGeom>
+          <a:solidFill>
+            <a:srgbClr val="F3E8FD"/>
+          </a:solidFill>
+          <a:ln/>
+        </p:spPr>
+      </p:sp>
+      <p:sp>
+        <p:nvSpPr>
+          <p:cNvPr id="27" name="Text 25"/>
+          <p:cNvSpPr txBox="1"/>
+          <p:nvPr/>
+        </p:nvSpPr>
+        <p:spPr>
+          <a:xfrm>
+            <a:off x="7973568" y="4069080"/>
+            <a:ext cx="292608" cy="237744"/>
+          </a:xfrm>
+          <a:prstGeom prst="rect">
+            <a:avLst/>
+          </a:prstGeom>
+          <a:noFill/>
+          <a:ln/>
+        </p:spPr>
+        <p:txBody>
+          <a:bodyPr wrap="square" lIns="0" tIns="0" rIns="0" bIns="0" rtlCol="0" anchor="ctr"/>
+          <a:lstStyle/>
+          <a:p>
+            <a:pPr algn="ctr" indent="0" marL="0">
+              <a:buNone/>
+            </a:pPr>
+            <a:r>
+              <a:rPr lang="en-US" sz="1250" b="1" dirty="0">
+                <a:solidFill>
+                  <a:srgbClr val="820AD1"/>
+                </a:solidFill>
+                <a:latin typeface="Arial" pitchFamily="34" charset="0"/>
+                <a:ea typeface="Arial" pitchFamily="34" charset="-122"/>
+                <a:cs typeface="Arial" pitchFamily="34" charset="-120"/>
+              </a:rPr>
+              <a:t>6</a:t>
+            </a:r>
+            <a:endParaRPr lang="en-US" sz="1250" dirty="0"/>
+          </a:p>
+        </p:txBody>
+      </p:sp>
+      <p:sp>
+        <p:nvSpPr>
+          <p:cNvPr id="28" name="Text 26"/>
+          <p:cNvSpPr txBox="1"/>
+          <p:nvPr/>
+        </p:nvSpPr>
+        <p:spPr>
+          <a:xfrm>
+            <a:off x="8375904" y="4023360"/>
+            <a:ext cx="3108960" cy="502920"/>
+          </a:xfrm>
+          <a:prstGeom prst="rect">
+            <a:avLst/>
+          </a:prstGeom>
+          <a:noFill/>
+          <a:ln/>
+        </p:spPr>
+        <p:txBody>
+          <a:bodyPr wrap="square" lIns="0" tIns="0" rIns="0" bIns="0" rtlCol="0" anchor="ctr"/>
+          <a:lstStyle/>
+          <a:p>
+            <a:pPr indent="0" marL="0">
+              <a:lnSpc>
+                <a:spcPts val="1600"/>
+              </a:lnSpc>
+              <a:buNone/>
+            </a:pPr>
+            <a:r>
+              <a:rPr lang="en-US" sz="1250" b="1" dirty="0">
+                <a:solidFill>
+                  <a:srgbClr val="19102A"/>
+                </a:solidFill>
+                <a:latin typeface="Arial" pitchFamily="34" charset="0"/>
+                <a:ea typeface="Arial" pitchFamily="34" charset="-122"/>
+                <a:cs typeface="Arial" pitchFamily="34" charset="-120"/>
+              </a:rPr>
+              <a:t>Put the disagreement in a test design.</a:t>
+            </a:r>
+            <a:endParaRPr lang="en-US" sz="1250" dirty="0"/>
+          </a:p>
+        </p:txBody>
+      </p:sp>
+      <p:sp>
+        <p:nvSpPr>
+          <p:cNvPr id="29" name="Text 27"/>
+          <p:cNvSpPr txBox="1"/>
+          <p:nvPr/>
+        </p:nvSpPr>
+        <p:spPr>
+          <a:xfrm>
+            <a:off x="8375904" y="4553712"/>
+            <a:ext cx="3063240" cy="1097280"/>
+          </a:xfrm>
+          <a:prstGeom prst="rect">
+            <a:avLst/>
+          </a:prstGeom>
+          <a:noFill/>
+          <a:ln/>
+        </p:spPr>
+        <p:txBody>
+          <a:bodyPr wrap="square" lIns="0" tIns="0" rIns="0" bIns="0" rtlCol="0" anchor="ctr"/>
+          <a:lstStyle/>
+          <a:p>
+            <a:pPr indent="0" marL="0">
+              <a:lnSpc>
+                <a:spcPts val="1500"/>
+              </a:lnSpc>
+              <a:buNone/>
+            </a:pPr>
+            <a:r>
+              <a:rPr lang="en-US" sz="1150" dirty="0">
+                <a:solidFill>
+                  <a:srgbClr val="2F2740"/>
+                </a:solidFill>
+                <a:latin typeface="Calibri" pitchFamily="34" charset="0"/>
+                <a:ea typeface="Calibri" pitchFamily="34" charset="-122"/>
+                <a:cs typeface="Calibri" pitchFamily="34" charset="-120"/>
+              </a:rPr>
+              <a:t>The fastest way to end a roadmap argument is to convert it into a testable question with a pre-agreed MDE and a guardrail metric the other team chooses. Then we argue about the design, which is solvable — instead of about priority, which is not.</a:t>
             </a:r>
             <a:endParaRPr lang="en-US" sz="1150" dirty="0"/>
           </a:p>
@@ -6485,7 +6628,7 @@
                 <a:ea typeface="Calibri" pitchFamily="34" charset="-122"/>
                 <a:cs typeface="Calibri" pitchFamily="34" charset="-120"/>
               </a:rPr>
-              <a:t>Segment β via a geographic holdout. Re-quote yield as a spread. Retire deposit growth in favour of deployable deposits and cost of funds against TIIE.</a:t>
+              <a:t>Run the gate test above as a geographic holdout, with MDE and guardrails pre-registered. Re-quote yield as a spread. Retire deposit growth in favour of deployable deposits and cost of funds against TIIE.</a:t>
             </a:r>
             <a:endParaRPr lang="en-US" sz="1150" dirty="0"/>
           </a:p>
@@ -14084,7 +14227,7 @@
             </a:avLst>
           </a:prstGeom>
           <a:solidFill>
-            <a:srgbClr val="FAF8FD"/>
+            <a:srgbClr val="F3E8FD"/>
           </a:solidFill>
           <a:ln w="12700">
             <a:solidFill>
@@ -14103,34 +14246,31 @@
         <p:spPr>
           <a:xfrm>
             <a:off x="8485632" y="1965960"/>
-            <a:ext cx="2926080" cy="548640"/>
-          </a:xfrm>
-          <a:prstGeom prst="rect">
-            <a:avLst/>
-          </a:prstGeom>
-          <a:noFill/>
-          <a:ln/>
-        </p:spPr>
-        <p:txBody>
-          <a:bodyPr wrap="square" lIns="0" tIns="0" rIns="0" bIns="0" rtlCol="0" anchor="ctr"/>
-          <a:lstStyle/>
-          <a:p>
-            <a:pPr indent="0" marL="0">
-              <a:lnSpc>
-                <a:spcPts val="1900"/>
-              </a:lnSpc>
+            <a:ext cx="2926080" cy="274320"/>
+          </a:xfrm>
+          <a:prstGeom prst="rect">
+            <a:avLst/>
+          </a:prstGeom>
+          <a:noFill/>
+          <a:ln/>
+        </p:spPr>
+        <p:txBody>
+          <a:bodyPr wrap="square" lIns="0" tIns="0" rIns="0" bIns="0" rtlCol="0" anchor="ctr"/>
+          <a:lstStyle/>
+          <a:p>
+            <a:pPr indent="0" marL="0">
               <a:buNone/>
             </a:pPr>
             <a:r>
               <a:rPr lang="en-US" sz="1400" b="1" dirty="0">
                 <a:solidFill>
-                  <a:srgbClr val="19102A"/>
+                  <a:srgbClr val="820AD1"/>
                 </a:solidFill>
                 <a:latin typeface="Arial" pitchFamily="34" charset="0"/>
                 <a:ea typeface="Arial" pitchFamily="34" charset="-122"/>
                 <a:cs typeface="Arial" pitchFamily="34" charset="-120"/>
               </a:rPr>
-              <a:t>Data I would ask for in week one</a:t>
+              <a:t>The first test I would run</a:t>
             </a:r>
             <a:endParaRPr lang="en-US" sz="1400" dirty="0"/>
           </a:p>
@@ -14144,31 +14284,66 @@
         </p:nvSpPr>
         <p:spPr>
           <a:xfrm>
-            <a:off x="8485632" y="2542032"/>
-            <a:ext cx="2926080" cy="2926080"/>
-          </a:xfrm>
-          <a:prstGeom prst="rect">
-            <a:avLst/>
-          </a:prstGeom>
-          <a:noFill/>
-          <a:ln/>
-        </p:spPr>
-        <p:txBody>
-          <a:bodyPr wrap="square" lIns="0" tIns="0" rIns="0" bIns="0" rtlCol="0" anchor="ctr"/>
-          <a:lstStyle/>
-          <a:p>
-            <a:pPr marL="342900" indent="-342900">
-              <a:lnSpc>
-                <a:spcPts val="1800"/>
-              </a:lnSpc>
-              <a:spcAft>
-                <a:spcPts val="700"/>
-              </a:spcAft>
-              <a:buSzPct val="100000"/>
-              <a:buChar char="•"/>
-            </a:pPr>
-            <a:r>
-              <a:rPr lang="en-US" sz="1150" dirty="0">
+            <a:off x="8485632" y="2331720"/>
+            <a:ext cx="868680" cy="237744"/>
+          </a:xfrm>
+          <a:prstGeom prst="rect">
+            <a:avLst/>
+          </a:prstGeom>
+          <a:noFill/>
+          <a:ln/>
+        </p:spPr>
+        <p:txBody>
+          <a:bodyPr wrap="square" lIns="0" tIns="0" rIns="0" bIns="0" rtlCol="0" anchor="ctr"/>
+          <a:lstStyle/>
+          <a:p>
+            <a:pPr indent="0" marL="0">
+              <a:buNone/>
+            </a:pPr>
+            <a:r>
+              <a:rPr lang="en-US" sz="900" b="1" spc="100" kern="0" dirty="0">
+                <a:solidFill>
+                  <a:srgbClr val="820AD1"/>
+                </a:solidFill>
+                <a:latin typeface="Arial" pitchFamily="34" charset="0"/>
+                <a:ea typeface="Arial" pitchFamily="34" charset="-122"/>
+                <a:cs typeface="Arial" pitchFamily="34" charset="-120"/>
+              </a:rPr>
+              <a:t>UNIT</a:t>
+            </a:r>
+            <a:endParaRPr lang="en-US" sz="900" dirty="0"/>
+          </a:p>
+        </p:txBody>
+      </p:sp>
+      <p:sp>
+        <p:nvSpPr>
+          <p:cNvPr id="24" name="Text 22"/>
+          <p:cNvSpPr txBox="1"/>
+          <p:nvPr/>
+        </p:nvSpPr>
+        <p:spPr>
+          <a:xfrm>
+            <a:off x="8485632" y="2514600"/>
+            <a:ext cx="2926080" cy="384048"/>
+          </a:xfrm>
+          <a:prstGeom prst="rect">
+            <a:avLst/>
+          </a:prstGeom>
+          <a:noFill/>
+          <a:ln/>
+        </p:spPr>
+        <p:txBody>
+          <a:bodyPr wrap="square" lIns="0" tIns="0" rIns="0" bIns="0" rtlCol="0" anchor="ctr"/>
+          <a:lstStyle/>
+          <a:p>
+            <a:pPr indent="0" marL="0">
+              <a:lnSpc>
+                <a:spcPts val="1400"/>
+              </a:lnSpc>
+              <a:buNone/>
+            </a:pPr>
+            <a:r>
+              <a:rPr lang="en-US" sz="1100" dirty="0">
                 <a:solidFill>
                   <a:srgbClr val="2F2740"/>
                 </a:solidFill>
@@ -14176,23 +14351,80 @@
                 <a:ea typeface="Calibri" pitchFamily="34" charset="-122"/>
                 <a:cs typeface="Calibri" pitchFamily="34" charset="-120"/>
               </a:rPr>
-              <a:t>Balance sensitivity by segment, from a geographic rate holdout — not a blended number</a:t>
-            </a:r>
-            <a:endParaRPr lang="en-US" sz="1150" dirty="0"/>
-          </a:p>
-          <a:p>
-            <a:pPr marL="342900" indent="-342900">
-              <a:lnSpc>
-                <a:spcPts val="1800"/>
-              </a:lnSpc>
-              <a:spcAft>
-                <a:spcPts val="700"/>
-              </a:spcAft>
-              <a:buSzPct val="100000"/>
-              <a:buChar char="•"/>
-            </a:pPr>
-            <a:r>
-              <a:rPr lang="en-US" sz="1150" dirty="0">
+              <a:t>Customer, randomised at the Turbo gate</a:t>
+            </a:r>
+            <a:endParaRPr lang="en-US" sz="1100" dirty="0"/>
+          </a:p>
+        </p:txBody>
+      </p:sp>
+      <p:sp>
+        <p:nvSpPr>
+          <p:cNvPr id="25" name="Text 23"/>
+          <p:cNvSpPr txBox="1"/>
+          <p:nvPr/>
+        </p:nvSpPr>
+        <p:spPr>
+          <a:xfrm>
+            <a:off x="8485632" y="2880360"/>
+            <a:ext cx="868680" cy="237744"/>
+          </a:xfrm>
+          <a:prstGeom prst="rect">
+            <a:avLst/>
+          </a:prstGeom>
+          <a:noFill/>
+          <a:ln/>
+        </p:spPr>
+        <p:txBody>
+          <a:bodyPr wrap="square" lIns="0" tIns="0" rIns="0" bIns="0" rtlCol="0" anchor="ctr"/>
+          <a:lstStyle/>
+          <a:p>
+            <a:pPr indent="0" marL="0">
+              <a:buNone/>
+            </a:pPr>
+            <a:r>
+              <a:rPr lang="en-US" sz="900" b="1" spc="100" kern="0" dirty="0">
+                <a:solidFill>
+                  <a:srgbClr val="820AD1"/>
+                </a:solidFill>
+                <a:latin typeface="Arial" pitchFamily="34" charset="0"/>
+                <a:ea typeface="Arial" pitchFamily="34" charset="-122"/>
+                <a:cs typeface="Arial" pitchFamily="34" charset="-120"/>
+              </a:rPr>
+              <a:t>ARMS</a:t>
+            </a:r>
+            <a:endParaRPr lang="en-US" sz="900" dirty="0"/>
+          </a:p>
+        </p:txBody>
+      </p:sp>
+      <p:sp>
+        <p:nvSpPr>
+          <p:cNvPr id="26" name="Text 24"/>
+          <p:cNvSpPr txBox="1"/>
+          <p:nvPr/>
+        </p:nvSpPr>
+        <p:spPr>
+          <a:xfrm>
+            <a:off x="8485632" y="3063240"/>
+            <a:ext cx="2926080" cy="384048"/>
+          </a:xfrm>
+          <a:prstGeom prst="rect">
+            <a:avLst/>
+          </a:prstGeom>
+          <a:noFill/>
+          <a:ln/>
+        </p:spPr>
+        <p:txBody>
+          <a:bodyPr wrap="square" lIns="0" tIns="0" rIns="0" bIns="0" rtlCol="0" anchor="ctr"/>
+          <a:lstStyle/>
+          <a:p>
+            <a:pPr indent="0" marL="0">
+              <a:lnSpc>
+                <a:spcPts val="1400"/>
+              </a:lnSpc>
+              <a:buNone/>
+            </a:pPr>
+            <a:r>
+              <a:rPr lang="en-US" sz="1100" dirty="0">
                 <a:solidFill>
                   <a:srgbClr val="2F2740"/>
                 </a:solidFill>
@@ -14200,23 +14432,80 @@
                 <a:ea typeface="Calibri" pitchFamily="34" charset="-122"/>
                 <a:cs typeface="Calibri" pitchFamily="34" charset="-120"/>
               </a:rPr>
-              <a:t>LTV by acquisition source: yield-acquired vs. income-acquired</a:t>
-            </a:r>
-            <a:endParaRPr lang="en-US" sz="1150" dirty="0"/>
-          </a:p>
-          <a:p>
-            <a:pPr marL="342900" indent="-342900">
-              <a:lnSpc>
-                <a:spcPts val="1800"/>
-              </a:lnSpc>
-              <a:spcAft>
-                <a:spcPts val="700"/>
-              </a:spcAft>
-              <a:buSzPct val="100000"/>
-              <a:buChar char="•"/>
-            </a:pPr>
-            <a:r>
-              <a:rPr lang="en-US" sz="1150" dirty="0">
+              <a:t>Premium gated on income landing, vs. on one card purchase, vs. control</a:t>
+            </a:r>
+            <a:endParaRPr lang="en-US" sz="1100" dirty="0"/>
+          </a:p>
+        </p:txBody>
+      </p:sp>
+      <p:sp>
+        <p:nvSpPr>
+          <p:cNvPr id="27" name="Text 25"/>
+          <p:cNvSpPr txBox="1"/>
+          <p:nvPr/>
+        </p:nvSpPr>
+        <p:spPr>
+          <a:xfrm>
+            <a:off x="8485632" y="3429000"/>
+            <a:ext cx="868680" cy="237744"/>
+          </a:xfrm>
+          <a:prstGeom prst="rect">
+            <a:avLst/>
+          </a:prstGeom>
+          <a:noFill/>
+          <a:ln/>
+        </p:spPr>
+        <p:txBody>
+          <a:bodyPr wrap="square" lIns="0" tIns="0" rIns="0" bIns="0" rtlCol="0" anchor="ctr"/>
+          <a:lstStyle/>
+          <a:p>
+            <a:pPr indent="0" marL="0">
+              <a:buNone/>
+            </a:pPr>
+            <a:r>
+              <a:rPr lang="en-US" sz="900" b="1" spc="100" kern="0" dirty="0">
+                <a:solidFill>
+                  <a:srgbClr val="820AD1"/>
+                </a:solidFill>
+                <a:latin typeface="Arial" pitchFamily="34" charset="0"/>
+                <a:ea typeface="Arial" pitchFamily="34" charset="-122"/>
+                <a:cs typeface="Arial" pitchFamily="34" charset="-120"/>
+              </a:rPr>
+              <a:t>PRIMARY</a:t>
+            </a:r>
+            <a:endParaRPr lang="en-US" sz="900" dirty="0"/>
+          </a:p>
+        </p:txBody>
+      </p:sp>
+      <p:sp>
+        <p:nvSpPr>
+          <p:cNvPr id="28" name="Text 26"/>
+          <p:cNvSpPr txBox="1"/>
+          <p:nvPr/>
+        </p:nvSpPr>
+        <p:spPr>
+          <a:xfrm>
+            <a:off x="8485632" y="3611880"/>
+            <a:ext cx="2926080" cy="384048"/>
+          </a:xfrm>
+          <a:prstGeom prst="rect">
+            <a:avLst/>
+          </a:prstGeom>
+          <a:noFill/>
+          <a:ln/>
+        </p:spPr>
+        <p:txBody>
+          <a:bodyPr wrap="square" lIns="0" tIns="0" rIns="0" bIns="0" rtlCol="0" anchor="ctr"/>
+          <a:lstStyle/>
+          <a:p>
+            <a:pPr indent="0" marL="0">
+              <a:lnSpc>
+                <a:spcPts val="1400"/>
+              </a:lnSpc>
+              <a:buNone/>
+            </a:pPr>
+            <a:r>
+              <a:rPr lang="en-US" sz="1100" dirty="0">
                 <a:solidFill>
                   <a:srgbClr val="2F2740"/>
                 </a:solidFill>
@@ -14224,23 +14513,80 @@
                 <a:ea typeface="Calibri" pitchFamily="34" charset="-122"/>
                 <a:cs typeface="Calibri" pitchFamily="34" charset="-120"/>
               </a:rPr>
-              <a:t>Balance concentration — does the premium cap even bind?</a:t>
-            </a:r>
-            <a:endParaRPr lang="en-US" sz="1150" dirty="0"/>
-          </a:p>
-          <a:p>
-            <a:pPr marL="342900" indent="-342900">
-              <a:lnSpc>
-                <a:spcPts val="1800"/>
-              </a:lnSpc>
-              <a:spcAft>
-                <a:spcPts val="700"/>
-              </a:spcAft>
-              <a:buSzPct val="100000"/>
-              <a:buChar char="•"/>
-            </a:pPr>
-            <a:r>
-              <a:rPr lang="en-US" sz="1150" dirty="0">
+              <a:t>Balance retention · blended cost of funds</a:t>
+            </a:r>
+            <a:endParaRPr lang="en-US" sz="1100" dirty="0"/>
+          </a:p>
+        </p:txBody>
+      </p:sp>
+      <p:sp>
+        <p:nvSpPr>
+          <p:cNvPr id="29" name="Text 27"/>
+          <p:cNvSpPr txBox="1"/>
+          <p:nvPr/>
+        </p:nvSpPr>
+        <p:spPr>
+          <a:xfrm>
+            <a:off x="8485632" y="3977640"/>
+            <a:ext cx="868680" cy="237744"/>
+          </a:xfrm>
+          <a:prstGeom prst="rect">
+            <a:avLst/>
+          </a:prstGeom>
+          <a:noFill/>
+          <a:ln/>
+        </p:spPr>
+        <p:txBody>
+          <a:bodyPr wrap="square" lIns="0" tIns="0" rIns="0" bIns="0" rtlCol="0" anchor="ctr"/>
+          <a:lstStyle/>
+          <a:p>
+            <a:pPr indent="0" marL="0">
+              <a:buNone/>
+            </a:pPr>
+            <a:r>
+              <a:rPr lang="en-US" sz="900" b="1" spc="100" kern="0" dirty="0">
+                <a:solidFill>
+                  <a:srgbClr val="820AD1"/>
+                </a:solidFill>
+                <a:latin typeface="Arial" pitchFamily="34" charset="0"/>
+                <a:ea typeface="Arial" pitchFamily="34" charset="-122"/>
+                <a:cs typeface="Arial" pitchFamily="34" charset="-120"/>
+              </a:rPr>
+              <a:t>GUARDRAIL</a:t>
+            </a:r>
+            <a:endParaRPr lang="en-US" sz="900" dirty="0"/>
+          </a:p>
+        </p:txBody>
+      </p:sp>
+      <p:sp>
+        <p:nvSpPr>
+          <p:cNvPr id="30" name="Text 28"/>
+          <p:cNvSpPr txBox="1"/>
+          <p:nvPr/>
+        </p:nvSpPr>
+        <p:spPr>
+          <a:xfrm>
+            <a:off x="8485632" y="4160520"/>
+            <a:ext cx="2926080" cy="384048"/>
+          </a:xfrm>
+          <a:prstGeom prst="rect">
+            <a:avLst/>
+          </a:prstGeom>
+          <a:noFill/>
+          <a:ln/>
+        </p:spPr>
+        <p:txBody>
+          <a:bodyPr wrap="square" lIns="0" tIns="0" rIns="0" bIns="0" rtlCol="0" anchor="ctr"/>
+          <a:lstStyle/>
+          <a:p>
+            <a:pPr indent="0" marL="0">
+              <a:lnSpc>
+                <a:spcPts val="1400"/>
+              </a:lnSpc>
+              <a:buNone/>
+            </a:pPr>
+            <a:r>
+              <a:rPr lang="en-US" sz="1100" dirty="0">
                 <a:solidFill>
                   <a:srgbClr val="2F2740"/>
                 </a:solidFill>
@@ -14248,23 +14594,80 @@
                 <a:ea typeface="Calibri" pitchFamily="34" charset="-122"/>
                 <a:cs typeface="Calibri" pitchFamily="34" charset="-120"/>
               </a:rPr>
-              <a:t>Attrition elasticity vs. the competitor gap, not vs. our own rate</a:t>
-            </a:r>
-            <a:endParaRPr lang="en-US" sz="1150" dirty="0"/>
-          </a:p>
-          <a:p>
-            <a:pPr marL="342900" indent="-342900">
-              <a:lnSpc>
-                <a:spcPts val="1800"/>
-              </a:lnSpc>
-              <a:spcAft>
-                <a:spcPts val="700"/>
-              </a:spcAft>
-              <a:buSzPct val="100000"/>
-              <a:buChar char="•"/>
-            </a:pPr>
-            <a:r>
-              <a:rPr lang="en-US" sz="1150" dirty="0">
+              <a:t>Card transaction volume — Card’s metric, agreed with them before launch</a:t>
+            </a:r>
+            <a:endParaRPr lang="en-US" sz="1100" dirty="0"/>
+          </a:p>
+        </p:txBody>
+      </p:sp>
+      <p:sp>
+        <p:nvSpPr>
+          <p:cNvPr id="31" name="Text 29"/>
+          <p:cNvSpPr txBox="1"/>
+          <p:nvPr/>
+        </p:nvSpPr>
+        <p:spPr>
+          <a:xfrm>
+            <a:off x="8485632" y="4526280"/>
+            <a:ext cx="868680" cy="237744"/>
+          </a:xfrm>
+          <a:prstGeom prst="rect">
+            <a:avLst/>
+          </a:prstGeom>
+          <a:noFill/>
+          <a:ln/>
+        </p:spPr>
+        <p:txBody>
+          <a:bodyPr wrap="square" lIns="0" tIns="0" rIns="0" bIns="0" rtlCol="0" anchor="ctr"/>
+          <a:lstStyle/>
+          <a:p>
+            <a:pPr indent="0" marL="0">
+              <a:buNone/>
+            </a:pPr>
+            <a:r>
+              <a:rPr lang="en-US" sz="900" b="1" spc="100" kern="0" dirty="0">
+                <a:solidFill>
+                  <a:srgbClr val="820AD1"/>
+                </a:solidFill>
+                <a:latin typeface="Arial" pitchFamily="34" charset="0"/>
+                <a:ea typeface="Arial" pitchFamily="34" charset="-122"/>
+                <a:cs typeface="Arial" pitchFamily="34" charset="-120"/>
+              </a:rPr>
+              <a:t>ACCEPT</a:t>
+            </a:r>
+            <a:endParaRPr lang="en-US" sz="900" dirty="0"/>
+          </a:p>
+        </p:txBody>
+      </p:sp>
+      <p:sp>
+        <p:nvSpPr>
+          <p:cNvPr id="32" name="Text 30"/>
+          <p:cNvSpPr txBox="1"/>
+          <p:nvPr/>
+        </p:nvSpPr>
+        <p:spPr>
+          <a:xfrm>
+            <a:off x="8485632" y="4709160"/>
+            <a:ext cx="2926080" cy="384048"/>
+          </a:xfrm>
+          <a:prstGeom prst="rect">
+            <a:avLst/>
+          </a:prstGeom>
+          <a:noFill/>
+          <a:ln/>
+        </p:spPr>
+        <p:txBody>
+          <a:bodyPr wrap="square" lIns="0" tIns="0" rIns="0" bIns="0" rtlCol="0" anchor="ctr"/>
+          <a:lstStyle/>
+          <a:p>
+            <a:pPr indent="0" marL="0">
+              <a:lnSpc>
+                <a:spcPts val="1400"/>
+              </a:lnSpc>
+              <a:buNone/>
+            </a:pPr>
+            <a:r>
+              <a:rPr lang="en-US" sz="1100" dirty="0">
                 <a:solidFill>
                   <a:srgbClr val="2F2740"/>
                 </a:solidFill>
@@ -14272,15 +14675,96 @@
                 <a:ea typeface="Calibri" pitchFamily="34" charset="-122"/>
                 <a:cs typeface="Calibri" pitchFamily="34" charset="-120"/>
               </a:rPr>
-              <a:t>Marginal risk-adjusted credit yield — is deployment actually accretive?</a:t>
-            </a:r>
-            <a:endParaRPr lang="en-US" sz="1150" dirty="0"/>
-          </a:p>
-        </p:txBody>
-      </p:sp>
-      <p:sp>
-        <p:nvSpPr>
-          <p:cNvPr id="24" name="Text 22"/>
+              <a:t>Neutral or positive contribution margin. Do no harm.</a:t>
+            </a:r>
+            <a:endParaRPr lang="en-US" sz="1100" dirty="0"/>
+          </a:p>
+        </p:txBody>
+      </p:sp>
+      <p:sp>
+        <p:nvSpPr>
+          <p:cNvPr id="33" name="Text 31"/>
+          <p:cNvSpPr txBox="1"/>
+          <p:nvPr/>
+        </p:nvSpPr>
+        <p:spPr>
+          <a:xfrm>
+            <a:off x="8485632" y="5074920"/>
+            <a:ext cx="868680" cy="237744"/>
+          </a:xfrm>
+          <a:prstGeom prst="rect">
+            <a:avLst/>
+          </a:prstGeom>
+          <a:noFill/>
+          <a:ln/>
+        </p:spPr>
+        <p:txBody>
+          <a:bodyPr wrap="square" lIns="0" tIns="0" rIns="0" bIns="0" rtlCol="0" anchor="ctr"/>
+          <a:lstStyle/>
+          <a:p>
+            <a:pPr indent="0" marL="0">
+              <a:buNone/>
+            </a:pPr>
+            <a:r>
+              <a:rPr lang="en-US" sz="900" b="1" spc="100" kern="0" dirty="0">
+                <a:solidFill>
+                  <a:srgbClr val="820AD1"/>
+                </a:solidFill>
+                <a:latin typeface="Arial" pitchFamily="34" charset="0"/>
+                <a:ea typeface="Arial" pitchFamily="34" charset="-122"/>
+                <a:cs typeface="Arial" pitchFamily="34" charset="-120"/>
+              </a:rPr>
+              <a:t>SET FIRST</a:t>
+            </a:r>
+            <a:endParaRPr lang="en-US" sz="900" dirty="0"/>
+          </a:p>
+        </p:txBody>
+      </p:sp>
+      <p:sp>
+        <p:nvSpPr>
+          <p:cNvPr id="34" name="Text 32"/>
+          <p:cNvSpPr txBox="1"/>
+          <p:nvPr/>
+        </p:nvSpPr>
+        <p:spPr>
+          <a:xfrm>
+            <a:off x="8485632" y="5257800"/>
+            <a:ext cx="2926080" cy="384048"/>
+          </a:xfrm>
+          <a:prstGeom prst="rect">
+            <a:avLst/>
+          </a:prstGeom>
+          <a:noFill/>
+          <a:ln/>
+        </p:spPr>
+        <p:txBody>
+          <a:bodyPr wrap="square" lIns="0" tIns="0" rIns="0" bIns="0" rtlCol="0" anchor="ctr"/>
+          <a:lstStyle/>
+          <a:p>
+            <a:pPr indent="0" marL="0">
+              <a:lnSpc>
+                <a:spcPts val="1400"/>
+              </a:lnSpc>
+              <a:buNone/>
+            </a:pPr>
+            <a:r>
+              <a:rPr lang="en-US" sz="1100" dirty="0">
+                <a:solidFill>
+                  <a:srgbClr val="2F2740"/>
+                </a:solidFill>
+                <a:latin typeface="Calibri" pitchFamily="34" charset="0"/>
+                <a:ea typeface="Calibri" pitchFamily="34" charset="-122"/>
+                <a:cs typeface="Calibri" pitchFamily="34" charset="-120"/>
+              </a:rPr>
+              <a:t>MDE and power before launch, never after</a:t>
+            </a:r>
+            <a:endParaRPr lang="en-US" sz="1100" dirty="0"/>
+          </a:p>
+        </p:txBody>
+      </p:sp>
+      <p:sp>
+        <p:nvSpPr>
+          <p:cNvPr id="35" name="Text 33"/>
           <p:cNvSpPr txBox="1"/>
           <p:nvPr/>
         </p:nvSpPr>

</xml_diff>

<commit_message>
Replace estimated evidence with the measured experiment results
Slide 10 now carries the intent-to-treat default reduction with its confidence
interval, and the funnel note that conditional on receiving the offer the two
timings performed the same, so the diluted difference came from coverage.

Slide 6 gains the sequencing evidence: a lightly personalised loan-number policy
captured roughly four fifths of what the full model achieved, which argues for
shipping the simple version first.

Deliberately not claiming coverage explains the whole gap - dilution at an equal
treated effect predicts 0.42pp against 0.96pp observed, so about half is coverage
and the rest is effect outside the offer group.

Adds Q and A for why ten days beat three and how much personalisation bought, and
flags two figures that need confirmation before use.

Co-Authored-By: Claude Opus 5 <noreply@anthropic.com>
Claude-Session: https://claude.ai/code/session_01W3HQLXSfDsZKWSgdamaReC
</commit_message>
<xml_diff>
--- a/deck/Core_Mexico_Business_Case.pptx
+++ b/deck/Core_Mexico_Business_Case.pptx
@@ -3504,27 +3504,27 @@
         </p:nvSpPr>
         <p:spPr>
           <a:xfrm>
-            <a:off x="8330184" y="3291840"/>
-            <a:ext cx="3063240" cy="1737360"/>
-          </a:xfrm>
-          <a:prstGeom prst="rect">
-            <a:avLst/>
-          </a:prstGeom>
-          <a:noFill/>
-          <a:ln/>
-        </p:spPr>
-        <p:txBody>
-          <a:bodyPr wrap="square" lIns="0" tIns="0" rIns="0" bIns="0" rtlCol="0" anchor="ctr"/>
-          <a:lstStyle/>
-          <a:p>
-            <a:pPr indent="0" marL="0">
-              <a:lnSpc>
-                <a:spcPts val="1650"/>
-              </a:lnSpc>
-              <a:buNone/>
-            </a:pPr>
-            <a:r>
-              <a:rPr lang="en-US" sz="1200" dirty="0">
+            <a:off x="8330184" y="3273552"/>
+            <a:ext cx="3063240" cy="713232"/>
+          </a:xfrm>
+          <a:prstGeom prst="rect">
+            <a:avLst/>
+          </a:prstGeom>
+          <a:noFill/>
+          <a:ln/>
+        </p:spPr>
+        <p:txBody>
+          <a:bodyPr wrap="square" lIns="0" tIns="0" rIns="0" bIns="0" rtlCol="0" anchor="ctr"/>
+          <a:lstStyle/>
+          <a:p>
+            <a:pPr indent="0" marL="0">
+              <a:lnSpc>
+                <a:spcPts val="1600"/>
+              </a:lnSpc>
+              <a:buNone/>
+            </a:pPr>
+            <a:r>
+              <a:rPr lang="en-US" sz="1150" dirty="0">
                 <a:solidFill>
                   <a:srgbClr val="2F2740"/>
                 </a:solidFill>
@@ -3532,28 +3532,119 @@
                 <a:ea typeface="Calibri" pitchFamily="34" charset="-122"/>
                 <a:cs typeface="Calibri" pitchFamily="34" charset="-120"/>
               </a:rPr>
-              <a:t>Score the customer as if they had repaid in full and on time — then show them the limit that unlocks.</a:t>
-            </a:r>
-            <a:endParaRPr lang="en-US" sz="1200" dirty="0"/>
-          </a:p>
-          <a:p>
-            <a:pPr indent="0" marL="0">
-              <a:lnSpc>
-                <a:spcPts val="1650"/>
-              </a:lnSpc>
-              <a:buNone/>
-            </a:pPr>
-            <a:endParaRPr lang="en-US" sz="1200" dirty="0"/>
-          </a:p>
-          <a:p>
-            <a:pPr indent="0" marL="0">
-              <a:lnSpc>
-                <a:spcPts val="1650"/>
-              </a:lnSpc>
-              <a:buNone/>
-            </a:pPr>
-            <a:r>
-              <a:rPr lang="en-US" sz="1200" dirty="0">
+              <a:t>Score the customer as if they had repaid on time, then show the limit that unlocks — a commitment, not a score.</a:t>
+            </a:r>
+            <a:endParaRPr lang="en-US" sz="1150" dirty="0"/>
+          </a:p>
+        </p:txBody>
+      </p:sp>
+      <p:sp>
+        <p:nvSpPr>
+          <p:cNvPr id="17" name="Text 15"/>
+          <p:cNvSpPr txBox="1"/>
+          <p:nvPr/>
+        </p:nvSpPr>
+        <p:spPr>
+          <a:xfrm>
+            <a:off x="8330184" y="4023360"/>
+            <a:ext cx="3063240" cy="219456"/>
+          </a:xfrm>
+          <a:prstGeom prst="rect">
+            <a:avLst/>
+          </a:prstGeom>
+          <a:noFill/>
+          <a:ln/>
+        </p:spPr>
+        <p:txBody>
+          <a:bodyPr wrap="square" lIns="0" tIns="0" rIns="0" bIns="0" rtlCol="0" anchor="ctr"/>
+          <a:lstStyle/>
+          <a:p>
+            <a:pPr indent="0" marL="0">
+              <a:buNone/>
+            </a:pPr>
+            <a:r>
+              <a:rPr lang="en-US" sz="950" b="1" spc="90" kern="0" dirty="0">
+                <a:solidFill>
+                  <a:srgbClr val="820AD1"/>
+                </a:solidFill>
+                <a:latin typeface="Arial" pitchFamily="34" charset="0"/>
+                <a:ea typeface="Arial" pitchFamily="34" charset="-122"/>
+                <a:cs typeface="Arial" pitchFamily="34" charset="-120"/>
+              </a:rPr>
+              <a:t>TESTED IN MÉXICO, THIS SEGMENT</a:t>
+            </a:r>
+            <a:endParaRPr lang="en-US" sz="950" dirty="0"/>
+          </a:p>
+        </p:txBody>
+      </p:sp>
+      <p:sp>
+        <p:nvSpPr>
+          <p:cNvPr id="18" name="Text 16"/>
+          <p:cNvSpPr txBox="1"/>
+          <p:nvPr/>
+        </p:nvSpPr>
+        <p:spPr>
+          <a:xfrm>
+            <a:off x="8330184" y="4242816"/>
+            <a:ext cx="3063240" cy="310896"/>
+          </a:xfrm>
+          <a:prstGeom prst="rect">
+            <a:avLst/>
+          </a:prstGeom>
+          <a:noFill/>
+          <a:ln/>
+        </p:spPr>
+        <p:txBody>
+          <a:bodyPr wrap="square" lIns="0" tIns="0" rIns="0" bIns="0" rtlCol="0" anchor="ctr"/>
+          <a:lstStyle/>
+          <a:p>
+            <a:pPr indent="0" marL="0">
+              <a:buNone/>
+            </a:pPr>
+            <a:r>
+              <a:rPr lang="en-US" sz="1700" b="1" dirty="0">
+                <a:solidFill>
+                  <a:srgbClr val="820AD1"/>
+                </a:solidFill>
+                <a:latin typeface="Arial" pitchFamily="34" charset="0"/>
+                <a:ea typeface="Arial" pitchFamily="34" charset="-122"/>
+                <a:cs typeface="Arial" pitchFamily="34" charset="-120"/>
+              </a:rPr>
+              <a:t>−1.43%</a:t>
+            </a:r>
+            <a:endParaRPr lang="en-US" sz="1700" dirty="0"/>
+          </a:p>
+        </p:txBody>
+      </p:sp>
+      <p:sp>
+        <p:nvSpPr>
+          <p:cNvPr id="19" name="Text 17"/>
+          <p:cNvSpPr txBox="1"/>
+          <p:nvPr/>
+        </p:nvSpPr>
+        <p:spPr>
+          <a:xfrm>
+            <a:off x="8330184" y="4572000"/>
+            <a:ext cx="3063240" cy="502920"/>
+          </a:xfrm>
+          <a:prstGeom prst="rect">
+            <a:avLst/>
+          </a:prstGeom>
+          <a:noFill/>
+          <a:ln/>
+        </p:spPr>
+        <p:txBody>
+          <a:bodyPr wrap="square" lIns="0" tIns="0" rIns="0" bIns="0" rtlCol="0" anchor="ctr"/>
+          <a:lstStyle/>
+          <a:p>
+            <a:pPr indent="0" marL="0">
+              <a:lnSpc>
+                <a:spcPts val="1350"/>
+              </a:lnSpc>
+              <a:buNone/>
+            </a:pPr>
+            <a:r>
+              <a:rPr lang="en-US" sz="1050" dirty="0">
                 <a:solidFill>
                   <a:srgbClr val="2F2740"/>
                 </a:solidFill>
@@ -3561,15 +3652,15 @@
                 <a:ea typeface="Calibri" pitchFamily="34" charset="-122"/>
                 <a:cs typeface="Calibri" pitchFamily="34" charset="-120"/>
               </a:rPr>
-              <a:t>That counterfactual is the only question a capped customer actually has: what would have to be different? And the answer is a commitment, not a score.</a:t>
-            </a:r>
-            <a:endParaRPr lang="en-US" sz="1200" dirty="0"/>
-          </a:p>
-        </p:txBody>
-      </p:sp>
-      <p:sp>
-        <p:nvSpPr>
-          <p:cNvPr id="17" name="Text 15"/>
+              <a:t>default rate, ITT, at 10 days pre-due. 95% CI −2.00 to −0.90. No significant move at 3 days.</a:t>
+            </a:r>
+            <a:endParaRPr lang="en-US" sz="1050" dirty="0"/>
+          </a:p>
+        </p:txBody>
+      </p:sp>
+      <p:sp>
+        <p:nvSpPr>
+          <p:cNvPr id="20" name="Text 18"/>
           <p:cNvSpPr txBox="1"/>
           <p:nvPr/>
         </p:nvSpPr>
@@ -3600,7 +3691,7 @@
                 <a:ea typeface="Calibri" pitchFamily="34" charset="-122"/>
                 <a:cs typeface="Calibri" pitchFamily="34" charset="-120"/>
               </a:rPr>
-              <a:t>I shipped this in México, to this segment. The non-obvious finding was timing — exposing a limit too early cuts default but gives the gain back through faster repayment cycles, so expose one personalised limit, and only as the due date approaches.</a:t>
+              <a:t>Conditional on receiving the offer, 3 days performed the same as 10 (−2.31% vs −2.25%). Ten days won the diluted read because more customers received an offer at all — 56% of loans against 38%.</a:t>
             </a:r>
             <a:endParaRPr lang="en-US" sz="950" dirty="0"/>
           </a:p>
@@ -13499,7 +13590,7 @@
                 <a:ea typeface="Calibri" pitchFamily="34" charset="-122"/>
                 <a:cs typeface="Calibri" pitchFamily="34" charset="-120"/>
               </a:rPr>
-              <a:t>Employer-side distribution is deliberately last: the incumbents have sold to HR for thirty years, and consumer pull is the only motion where a challenger starts ahead.</a:t>
+              <a:t>And ship the simple version first: when I tested this in México, a plain loan-number ladder captured about four fifths of what a fully personalised causal model achieved. Personalisation earns its place later.</a:t>
             </a:r>
             <a:endParaRPr lang="en-US" sz="950" dirty="0"/>
           </a:p>

</xml_diff>